<commit_message>
rearranging and adding plots
</commit_message>
<xml_diff>
--- a/Presentations/Draft plots for myography trade-off work.pptx
+++ b/Presentations/Draft plots for myography trade-off work.pptx
@@ -5,27 +5,31 @@
     <p:sldMasterId id="2147483648" r:id="rId1"/>
   </p:sldMasterIdLst>
   <p:notesMasterIdLst>
-    <p:notesMasterId r:id="rId20"/>
+    <p:notesMasterId r:id="rId24"/>
   </p:notesMasterIdLst>
   <p:sldIdLst>
     <p:sldId id="274" r:id="rId2"/>
     <p:sldId id="256" r:id="rId3"/>
-    <p:sldId id="257" r:id="rId4"/>
-    <p:sldId id="258" r:id="rId5"/>
-    <p:sldId id="259" r:id="rId6"/>
-    <p:sldId id="261" r:id="rId7"/>
-    <p:sldId id="260" r:id="rId8"/>
-    <p:sldId id="262" r:id="rId9"/>
-    <p:sldId id="263" r:id="rId10"/>
-    <p:sldId id="264" r:id="rId11"/>
-    <p:sldId id="265" r:id="rId12"/>
-    <p:sldId id="272" r:id="rId13"/>
-    <p:sldId id="267" r:id="rId14"/>
-    <p:sldId id="271" r:id="rId15"/>
-    <p:sldId id="269" r:id="rId16"/>
-    <p:sldId id="268" r:id="rId17"/>
-    <p:sldId id="270" r:id="rId18"/>
-    <p:sldId id="273" r:id="rId19"/>
+    <p:sldId id="275" r:id="rId4"/>
+    <p:sldId id="257" r:id="rId5"/>
+    <p:sldId id="277" r:id="rId6"/>
+    <p:sldId id="258" r:id="rId7"/>
+    <p:sldId id="259" r:id="rId8"/>
+    <p:sldId id="261" r:id="rId9"/>
+    <p:sldId id="260" r:id="rId10"/>
+    <p:sldId id="262" r:id="rId11"/>
+    <p:sldId id="263" r:id="rId12"/>
+    <p:sldId id="264" r:id="rId13"/>
+    <p:sldId id="276" r:id="rId14"/>
+    <p:sldId id="265" r:id="rId15"/>
+    <p:sldId id="278" r:id="rId16"/>
+    <p:sldId id="272" r:id="rId17"/>
+    <p:sldId id="267" r:id="rId18"/>
+    <p:sldId id="271" r:id="rId19"/>
+    <p:sldId id="269" r:id="rId20"/>
+    <p:sldId id="268" r:id="rId21"/>
+    <p:sldId id="270" r:id="rId22"/>
+    <p:sldId id="273" r:id="rId23"/>
   </p:sldIdLst>
   <p:sldSz cx="12192000" cy="6858000"/>
   <p:notesSz cx="6858000" cy="9144000"/>
@@ -124,6 +128,11 @@
       </a:defRPr>
     </a:lvl9pPr>
   </p:defaultTextStyle>
+  <p:extLst>
+    <p:ext uri="{EFAFB233-063F-42B5-8137-9DF3F51BA10A}">
+      <p15:sldGuideLst xmlns:p15="http://schemas.microsoft.com/office/powerpoint/2012/main"/>
+    </p:ext>
+  </p:extLst>
 </p:presentation>
 </file>
 
@@ -209,7 +218,7 @@
           <a:p>
             <a:fld id="{3930ABBD-3C32-42F1-9CAF-983C4BE0028E}" type="datetimeFigureOut">
               <a:rPr lang="en-US" smtClean="0"/>
-              <a:t>6/7/2026</a:t>
+              <a:t>6/10/2026</a:t>
             </a:fld>
             <a:endParaRPr lang="en-US"/>
           </a:p>
@@ -544,7 +553,7 @@
           <a:p>
             <a:fld id="{F7EB3A0C-D451-48F2-9233-B0BC11E987C5}" type="slidenum">
               <a:rPr lang="en-US" smtClean="0"/>
-              <a:t>3</a:t>
+              <a:t>4</a:t>
             </a:fld>
             <a:endParaRPr lang="en-US"/>
           </a:p>
@@ -631,7 +640,7 @@
           <a:p>
             <a:fld id="{F7EB3A0C-D451-48F2-9233-B0BC11E987C5}" type="slidenum">
               <a:rPr lang="en-US" smtClean="0"/>
-              <a:t>13</a:t>
+              <a:t>17</a:t>
             </a:fld>
             <a:endParaRPr lang="en-US"/>
           </a:p>
@@ -723,7 +732,7 @@
           <a:p>
             <a:fld id="{F7EB3A0C-D451-48F2-9233-B0BC11E987C5}" type="slidenum">
               <a:rPr lang="en-US" smtClean="0"/>
-              <a:t>14</a:t>
+              <a:t>18</a:t>
             </a:fld>
             <a:endParaRPr lang="en-US"/>
           </a:p>
@@ -810,7 +819,7 @@
           <a:p>
             <a:fld id="{F7EB3A0C-D451-48F2-9233-B0BC11E987C5}" type="slidenum">
               <a:rPr lang="en-US" smtClean="0"/>
-              <a:t>15</a:t>
+              <a:t>19</a:t>
             </a:fld>
             <a:endParaRPr lang="en-US"/>
           </a:p>
@@ -897,7 +906,7 @@
           <a:p>
             <a:fld id="{F7EB3A0C-D451-48F2-9233-B0BC11E987C5}" type="slidenum">
               <a:rPr lang="en-US" smtClean="0"/>
-              <a:t>16</a:t>
+              <a:t>20</a:t>
             </a:fld>
             <a:endParaRPr lang="en-US"/>
           </a:p>
@@ -984,7 +993,7 @@
           <a:p>
             <a:fld id="{F7EB3A0C-D451-48F2-9233-B0BC11E987C5}" type="slidenum">
               <a:rPr lang="en-US" smtClean="0"/>
-              <a:t>17</a:t>
+              <a:t>21</a:t>
             </a:fld>
             <a:endParaRPr lang="en-US"/>
           </a:p>
@@ -1071,7 +1080,7 @@
           <a:p>
             <a:fld id="{F7EB3A0C-D451-48F2-9233-B0BC11E987C5}" type="slidenum">
               <a:rPr lang="en-US" smtClean="0"/>
-              <a:t>4</a:t>
+              <a:t>6</a:t>
             </a:fld>
             <a:endParaRPr lang="en-US"/>
           </a:p>
@@ -1178,7 +1187,7 @@
           <a:p>
             <a:fld id="{F7EB3A0C-D451-48F2-9233-B0BC11E987C5}" type="slidenum">
               <a:rPr lang="en-US" smtClean="0"/>
-              <a:t>5</a:t>
+              <a:t>7</a:t>
             </a:fld>
             <a:endParaRPr lang="en-US"/>
           </a:p>
@@ -1290,7 +1299,7 @@
           <a:p>
             <a:fld id="{F7EB3A0C-D451-48F2-9233-B0BC11E987C5}" type="slidenum">
               <a:rPr lang="en-US" smtClean="0"/>
-              <a:t>6</a:t>
+              <a:t>8</a:t>
             </a:fld>
             <a:endParaRPr lang="en-US"/>
           </a:p>
@@ -1385,7 +1394,7 @@
           <a:p>
             <a:fld id="{F7EB3A0C-D451-48F2-9233-B0BC11E987C5}" type="slidenum">
               <a:rPr lang="en-US" smtClean="0"/>
-              <a:t>7</a:t>
+              <a:t>9</a:t>
             </a:fld>
             <a:endParaRPr lang="en-US"/>
           </a:p>
@@ -1472,7 +1481,7 @@
           <a:p>
             <a:fld id="{F7EB3A0C-D451-48F2-9233-B0BC11E987C5}" type="slidenum">
               <a:rPr lang="en-US" smtClean="0"/>
-              <a:t>8</a:t>
+              <a:t>10</a:t>
             </a:fld>
             <a:endParaRPr lang="en-US"/>
           </a:p>
@@ -1559,7 +1568,7 @@
           <a:p>
             <a:fld id="{F7EB3A0C-D451-48F2-9233-B0BC11E987C5}" type="slidenum">
               <a:rPr lang="en-US" smtClean="0"/>
-              <a:t>9</a:t>
+              <a:t>11</a:t>
             </a:fld>
             <a:endParaRPr lang="en-US"/>
           </a:p>
@@ -1646,7 +1655,7 @@
           <a:p>
             <a:fld id="{F7EB3A0C-D451-48F2-9233-B0BC11E987C5}" type="slidenum">
               <a:rPr lang="en-US" smtClean="0"/>
-              <a:t>11</a:t>
+              <a:t>14</a:t>
             </a:fld>
             <a:endParaRPr lang="en-US"/>
           </a:p>
@@ -1741,7 +1750,7 @@
           <a:p>
             <a:fld id="{F7EB3A0C-D451-48F2-9233-B0BC11E987C5}" type="slidenum">
               <a:rPr lang="en-US" smtClean="0"/>
-              <a:t>12</a:t>
+              <a:t>16</a:t>
             </a:fld>
             <a:endParaRPr lang="en-US"/>
           </a:p>
@@ -1907,7 +1916,7 @@
           <a:p>
             <a:fld id="{8D0B3E90-267C-48FC-B90C-EF83BC81CA30}" type="datetimeFigureOut">
               <a:rPr lang="en-US" smtClean="0"/>
-              <a:t>6/7/2026</a:t>
+              <a:t>6/10/2026</a:t>
             </a:fld>
             <a:endParaRPr lang="en-US"/>
           </a:p>
@@ -2105,7 +2114,7 @@
           <a:p>
             <a:fld id="{8D0B3E90-267C-48FC-B90C-EF83BC81CA30}" type="datetimeFigureOut">
               <a:rPr lang="en-US" smtClean="0"/>
-              <a:t>6/7/2026</a:t>
+              <a:t>6/10/2026</a:t>
             </a:fld>
             <a:endParaRPr lang="en-US"/>
           </a:p>
@@ -2313,7 +2322,7 @@
           <a:p>
             <a:fld id="{8D0B3E90-267C-48FC-B90C-EF83BC81CA30}" type="datetimeFigureOut">
               <a:rPr lang="en-US" smtClean="0"/>
-              <a:t>6/7/2026</a:t>
+              <a:t>6/10/2026</a:t>
             </a:fld>
             <a:endParaRPr lang="en-US"/>
           </a:p>
@@ -2511,7 +2520,7 @@
           <a:p>
             <a:fld id="{8D0B3E90-267C-48FC-B90C-EF83BC81CA30}" type="datetimeFigureOut">
               <a:rPr lang="en-US" smtClean="0"/>
-              <a:t>6/7/2026</a:t>
+              <a:t>6/10/2026</a:t>
             </a:fld>
             <a:endParaRPr lang="en-US"/>
           </a:p>
@@ -2786,7 +2795,7 @@
           <a:p>
             <a:fld id="{8D0B3E90-267C-48FC-B90C-EF83BC81CA30}" type="datetimeFigureOut">
               <a:rPr lang="en-US" smtClean="0"/>
-              <a:t>6/7/2026</a:t>
+              <a:t>6/10/2026</a:t>
             </a:fld>
             <a:endParaRPr lang="en-US"/>
           </a:p>
@@ -3051,7 +3060,7 @@
           <a:p>
             <a:fld id="{8D0B3E90-267C-48FC-B90C-EF83BC81CA30}" type="datetimeFigureOut">
               <a:rPr lang="en-US" smtClean="0"/>
-              <a:t>6/7/2026</a:t>
+              <a:t>6/10/2026</a:t>
             </a:fld>
             <a:endParaRPr lang="en-US"/>
           </a:p>
@@ -3463,7 +3472,7 @@
           <a:p>
             <a:fld id="{8D0B3E90-267C-48FC-B90C-EF83BC81CA30}" type="datetimeFigureOut">
               <a:rPr lang="en-US" smtClean="0"/>
-              <a:t>6/7/2026</a:t>
+              <a:t>6/10/2026</a:t>
             </a:fld>
             <a:endParaRPr lang="en-US"/>
           </a:p>
@@ -3604,7 +3613,7 @@
           <a:p>
             <a:fld id="{8D0B3E90-267C-48FC-B90C-EF83BC81CA30}" type="datetimeFigureOut">
               <a:rPr lang="en-US" smtClean="0"/>
-              <a:t>6/7/2026</a:t>
+              <a:t>6/10/2026</a:t>
             </a:fld>
             <a:endParaRPr lang="en-US"/>
           </a:p>
@@ -3717,7 +3726,7 @@
           <a:p>
             <a:fld id="{8D0B3E90-267C-48FC-B90C-EF83BC81CA30}" type="datetimeFigureOut">
               <a:rPr lang="en-US" smtClean="0"/>
-              <a:t>6/7/2026</a:t>
+              <a:t>6/10/2026</a:t>
             </a:fld>
             <a:endParaRPr lang="en-US"/>
           </a:p>
@@ -4028,7 +4037,7 @@
           <a:p>
             <a:fld id="{8D0B3E90-267C-48FC-B90C-EF83BC81CA30}" type="datetimeFigureOut">
               <a:rPr lang="en-US" smtClean="0"/>
-              <a:t>6/7/2026</a:t>
+              <a:t>6/10/2026</a:t>
             </a:fld>
             <a:endParaRPr lang="en-US"/>
           </a:p>
@@ -4316,7 +4325,7 @@
           <a:p>
             <a:fld id="{8D0B3E90-267C-48FC-B90C-EF83BC81CA30}" type="datetimeFigureOut">
               <a:rPr lang="en-US" smtClean="0"/>
-              <a:t>6/7/2026</a:t>
+              <a:t>6/10/2026</a:t>
             </a:fld>
             <a:endParaRPr lang="en-US"/>
           </a:p>
@@ -4557,7 +4566,7 @@
           <a:p>
             <a:fld id="{8D0B3E90-267C-48FC-B90C-EF83BC81CA30}" type="datetimeFigureOut">
               <a:rPr lang="en-US" smtClean="0"/>
-              <a:t>6/7/2026</a:t>
+              <a:t>6/10/2026</a:t>
             </a:fld>
             <a:endParaRPr lang="en-US"/>
           </a:p>
@@ -5045,1503 +5054,6 @@
   <p:cSld>
     <p:spTree>
       <p:nvGrpSpPr>
-        <p:cNvPr id="1" name=""/>
-        <p:cNvGrpSpPr/>
-        <p:nvPr/>
-      </p:nvGrpSpPr>
-      <p:grpSpPr>
-        <a:xfrm>
-          <a:off x="0" y="0"/>
-          <a:ext cx="0" cy="0"/>
-          <a:chOff x="0" y="0"/>
-          <a:chExt cx="0" cy="0"/>
-        </a:xfrm>
-      </p:grpSpPr>
-      <p:sp>
-        <p:nvSpPr>
-          <p:cNvPr id="2" name="Title 1">
-            <a:extLst>
-              <a:ext uri="{FF2B5EF4-FFF2-40B4-BE49-F238E27FC236}">
-                <a16:creationId xmlns:a16="http://schemas.microsoft.com/office/drawing/2014/main" id="{F22E7229-A7F7-248B-E6F8-BE83DB34ADB7}"/>
-              </a:ext>
-            </a:extLst>
-          </p:cNvPr>
-          <p:cNvSpPr>
-            <a:spLocks noGrp="1"/>
-          </p:cNvSpPr>
-          <p:nvPr>
-            <p:ph type="title"/>
-          </p:nvPr>
-        </p:nvSpPr>
-        <p:spPr/>
-        <p:txBody>
-          <a:bodyPr/>
-          <a:lstStyle/>
-          <a:p>
-            <a:r>
-              <a:rPr lang="en-US" dirty="0"/>
-              <a:t>Tetanic contractions (tetanus)</a:t>
-            </a:r>
-          </a:p>
-        </p:txBody>
-      </p:sp>
-      <p:sp>
-        <p:nvSpPr>
-          <p:cNvPr id="3" name="Text Placeholder 2">
-            <a:extLst>
-              <a:ext uri="{FF2B5EF4-FFF2-40B4-BE49-F238E27FC236}">
-                <a16:creationId xmlns:a16="http://schemas.microsoft.com/office/drawing/2014/main" id="{3A446006-E94C-5109-981F-0EE1E9215759}"/>
-              </a:ext>
-            </a:extLst>
-          </p:cNvPr>
-          <p:cNvSpPr>
-            <a:spLocks noGrp="1"/>
-          </p:cNvSpPr>
-          <p:nvPr>
-            <p:ph type="body" idx="1"/>
-          </p:nvPr>
-        </p:nvSpPr>
-        <p:spPr/>
-        <p:txBody>
-          <a:bodyPr/>
-          <a:lstStyle/>
-          <a:p>
-            <a:r>
-              <a:rPr lang="en-US" dirty="0"/>
-              <a:t>Same note about the colors, apologies that they’re all wonky again</a:t>
-            </a:r>
-          </a:p>
-        </p:txBody>
-      </p:sp>
-    </p:spTree>
-    <p:extLst>
-      <p:ext uri="{BB962C8B-B14F-4D97-AF65-F5344CB8AC3E}">
-        <p14:creationId xmlns:p14="http://schemas.microsoft.com/office/powerpoint/2010/main" val="1388248658"/>
-      </p:ext>
-    </p:extLst>
-  </p:cSld>
-  <p:clrMapOvr>
-    <a:masterClrMapping/>
-  </p:clrMapOvr>
-</p:sld>
-</file>
-
-<file path=ppt/slides/slide11.xml><?xml version="1.0" encoding="utf-8"?>
-<p:sld xmlns:a="http://schemas.openxmlformats.org/drawingml/2006/main" xmlns:r="http://schemas.openxmlformats.org/officeDocument/2006/relationships" xmlns:p="http://schemas.openxmlformats.org/presentationml/2006/main">
-  <p:cSld>
-    <p:spTree>
-      <p:nvGrpSpPr>
-        <p:cNvPr id="1" name=""/>
-        <p:cNvGrpSpPr/>
-        <p:nvPr/>
-      </p:nvGrpSpPr>
-      <p:grpSpPr>
-        <a:xfrm>
-          <a:off x="0" y="0"/>
-          <a:ext cx="0" cy="0"/>
-          <a:chOff x="0" y="0"/>
-          <a:chExt cx="0" cy="0"/>
-        </a:xfrm>
-      </p:grpSpPr>
-      <p:pic>
-        <p:nvPicPr>
-          <p:cNvPr id="18" name="Picture 17">
-            <a:extLst>
-              <a:ext uri="{FF2B5EF4-FFF2-40B4-BE49-F238E27FC236}">
-                <a16:creationId xmlns:a16="http://schemas.microsoft.com/office/drawing/2014/main" id="{3D69B59F-D994-2285-6033-2FB458B34C42}"/>
-              </a:ext>
-            </a:extLst>
-          </p:cNvPr>
-          <p:cNvPicPr>
-            <a:picLocks noChangeAspect="1"/>
-          </p:cNvPicPr>
-          <p:nvPr/>
-        </p:nvPicPr>
-        <p:blipFill>
-          <a:blip r:embed="rId3">
-            <a:extLst>
-              <a:ext uri="{28A0092B-C50C-407E-A947-70E740481C1C}">
-                <a14:useLocalDpi xmlns:a14="http://schemas.microsoft.com/office/drawing/2010/main" val="0"/>
-              </a:ext>
-            </a:extLst>
-          </a:blip>
-          <a:stretch>
-            <a:fillRect/>
-          </a:stretch>
-        </p:blipFill>
-        <p:spPr>
-          <a:xfrm>
-            <a:off x="1746667" y="239641"/>
-            <a:ext cx="7702133" cy="6378718"/>
-          </a:xfrm>
-          <a:prstGeom prst="rect">
-            <a:avLst/>
-          </a:prstGeom>
-        </p:spPr>
-      </p:pic>
-    </p:spTree>
-    <p:extLst>
-      <p:ext uri="{BB962C8B-B14F-4D97-AF65-F5344CB8AC3E}">
-        <p14:creationId xmlns:p14="http://schemas.microsoft.com/office/powerpoint/2010/main" val="1887341186"/>
-      </p:ext>
-    </p:extLst>
-  </p:cSld>
-  <p:clrMapOvr>
-    <a:masterClrMapping/>
-  </p:clrMapOvr>
-</p:sld>
-</file>
-
-<file path=ppt/slides/slide12.xml><?xml version="1.0" encoding="utf-8"?>
-<p:sld xmlns:a="http://schemas.openxmlformats.org/drawingml/2006/main" xmlns:r="http://schemas.openxmlformats.org/officeDocument/2006/relationships" xmlns:p="http://schemas.openxmlformats.org/presentationml/2006/main">
-  <p:cSld>
-    <p:spTree>
-      <p:nvGrpSpPr>
-        <p:cNvPr id="1" name="">
-          <a:extLst>
-            <a:ext uri="{FF2B5EF4-FFF2-40B4-BE49-F238E27FC236}">
-              <a16:creationId xmlns:a16="http://schemas.microsoft.com/office/drawing/2014/main" id="{E0D1D141-BF55-6CFA-D0D4-E2DF47FE6C02}"/>
-            </a:ext>
-          </a:extLst>
-        </p:cNvPr>
-        <p:cNvGrpSpPr/>
-        <p:nvPr/>
-      </p:nvGrpSpPr>
-      <p:grpSpPr>
-        <a:xfrm>
-          <a:off x="0" y="0"/>
-          <a:ext cx="0" cy="0"/>
-          <a:chOff x="0" y="0"/>
-          <a:chExt cx="0" cy="0"/>
-        </a:xfrm>
-      </p:grpSpPr>
-      <p:sp>
-        <p:nvSpPr>
-          <p:cNvPr id="4" name="Title 3">
-            <a:extLst>
-              <a:ext uri="{FF2B5EF4-FFF2-40B4-BE49-F238E27FC236}">
-                <a16:creationId xmlns:a16="http://schemas.microsoft.com/office/drawing/2014/main" id="{F742240D-C979-78B2-8631-D9A15E3CC603}"/>
-              </a:ext>
-            </a:extLst>
-          </p:cNvPr>
-          <p:cNvSpPr>
-            <a:spLocks noGrp="1"/>
-          </p:cNvSpPr>
-          <p:nvPr>
-            <p:ph type="title"/>
-          </p:nvPr>
-        </p:nvSpPr>
-        <p:spPr>
-          <a:xfrm>
-            <a:off x="159774" y="70158"/>
-            <a:ext cx="10515600" cy="1325563"/>
-          </a:xfrm>
-        </p:spPr>
-        <p:txBody>
-          <a:bodyPr/>
-          <a:lstStyle/>
-          <a:p>
-            <a:r>
-              <a:rPr lang="en-US" dirty="0"/>
-              <a:t>LVNV, T, and WT sirtalis</a:t>
-            </a:r>
-          </a:p>
-        </p:txBody>
-      </p:sp>
-      <p:pic>
-        <p:nvPicPr>
-          <p:cNvPr id="16" name="Picture 15">
-            <a:extLst>
-              <a:ext uri="{FF2B5EF4-FFF2-40B4-BE49-F238E27FC236}">
-                <a16:creationId xmlns:a16="http://schemas.microsoft.com/office/drawing/2014/main" id="{0FAC8C6F-5236-4C3D-4ADB-86FFAE71D67C}"/>
-              </a:ext>
-            </a:extLst>
-          </p:cNvPr>
-          <p:cNvPicPr>
-            <a:picLocks noChangeAspect="1"/>
-          </p:cNvPicPr>
-          <p:nvPr/>
-        </p:nvPicPr>
-        <p:blipFill>
-          <a:blip r:embed="rId3">
-            <a:extLst>
-              <a:ext uri="{28A0092B-C50C-407E-A947-70E740481C1C}">
-                <a14:useLocalDpi xmlns:a14="http://schemas.microsoft.com/office/drawing/2010/main" val="0"/>
-              </a:ext>
-            </a:extLst>
-          </a:blip>
-          <a:stretch>
-            <a:fillRect/>
-          </a:stretch>
-        </p:blipFill>
-        <p:spPr>
-          <a:xfrm>
-            <a:off x="2796533" y="1155851"/>
-            <a:ext cx="6598933" cy="5465075"/>
-          </a:xfrm>
-          <a:prstGeom prst="rect">
-            <a:avLst/>
-          </a:prstGeom>
-        </p:spPr>
-      </p:pic>
-    </p:spTree>
-    <p:extLst>
-      <p:ext uri="{BB962C8B-B14F-4D97-AF65-F5344CB8AC3E}">
-        <p14:creationId xmlns:p14="http://schemas.microsoft.com/office/powerpoint/2010/main" val="701903127"/>
-      </p:ext>
-    </p:extLst>
-  </p:cSld>
-  <p:clrMapOvr>
-    <a:masterClrMapping/>
-  </p:clrMapOvr>
-</p:sld>
-</file>
-
-<file path=ppt/slides/slide13.xml><?xml version="1.0" encoding="utf-8"?>
-<p:sld xmlns:a="http://schemas.openxmlformats.org/drawingml/2006/main" xmlns:r="http://schemas.openxmlformats.org/officeDocument/2006/relationships" xmlns:p="http://schemas.openxmlformats.org/presentationml/2006/main">
-  <p:cSld>
-    <p:spTree>
-      <p:nvGrpSpPr>
-        <p:cNvPr id="1" name="">
-          <a:extLst>
-            <a:ext uri="{FF2B5EF4-FFF2-40B4-BE49-F238E27FC236}">
-              <a16:creationId xmlns:a16="http://schemas.microsoft.com/office/drawing/2014/main" id="{F49B1AFC-8B86-2BEB-43D5-CB26CC07E4D1}"/>
-            </a:ext>
-          </a:extLst>
-        </p:cNvPr>
-        <p:cNvGrpSpPr/>
-        <p:nvPr/>
-      </p:nvGrpSpPr>
-      <p:grpSpPr>
-        <a:xfrm>
-          <a:off x="0" y="0"/>
-          <a:ext cx="0" cy="0"/>
-          <a:chOff x="0" y="0"/>
-          <a:chExt cx="0" cy="0"/>
-        </a:xfrm>
-      </p:grpSpPr>
-      <p:sp>
-        <p:nvSpPr>
-          <p:cNvPr id="4" name="Title 3">
-            <a:extLst>
-              <a:ext uri="{FF2B5EF4-FFF2-40B4-BE49-F238E27FC236}">
-                <a16:creationId xmlns:a16="http://schemas.microsoft.com/office/drawing/2014/main" id="{427A2538-AA41-71FA-61B6-FE951563DB19}"/>
-              </a:ext>
-            </a:extLst>
-          </p:cNvPr>
-          <p:cNvSpPr>
-            <a:spLocks noGrp="1"/>
-          </p:cNvSpPr>
-          <p:nvPr>
-            <p:ph type="title"/>
-          </p:nvPr>
-        </p:nvSpPr>
-        <p:spPr>
-          <a:xfrm>
-            <a:off x="81116" y="0"/>
-            <a:ext cx="10515600" cy="1325563"/>
-          </a:xfrm>
-        </p:spPr>
-        <p:txBody>
-          <a:bodyPr/>
-          <a:lstStyle/>
-          <a:p>
-            <a:r>
-              <a:rPr lang="en-US" dirty="0"/>
-              <a:t>LVNV, EPN, T, and WT sirtalis</a:t>
-            </a:r>
-          </a:p>
-        </p:txBody>
-      </p:sp>
-      <p:pic>
-        <p:nvPicPr>
-          <p:cNvPr id="6" name="Picture 5">
-            <a:extLst>
-              <a:ext uri="{FF2B5EF4-FFF2-40B4-BE49-F238E27FC236}">
-                <a16:creationId xmlns:a16="http://schemas.microsoft.com/office/drawing/2014/main" id="{EC278E12-1BA9-99C0-B3E6-FDB4D1AF1D09}"/>
-              </a:ext>
-            </a:extLst>
-          </p:cNvPr>
-          <p:cNvPicPr>
-            <a:picLocks noChangeAspect="1"/>
-          </p:cNvPicPr>
-          <p:nvPr/>
-        </p:nvPicPr>
-        <p:blipFill>
-          <a:blip r:embed="rId3">
-            <a:extLst>
-              <a:ext uri="{28A0092B-C50C-407E-A947-70E740481C1C}">
-                <a14:useLocalDpi xmlns:a14="http://schemas.microsoft.com/office/drawing/2010/main" val="0"/>
-              </a:ext>
-            </a:extLst>
-          </a:blip>
-          <a:stretch>
-            <a:fillRect/>
-          </a:stretch>
-        </p:blipFill>
-        <p:spPr>
-          <a:xfrm>
-            <a:off x="2602718" y="1001263"/>
-            <a:ext cx="6986564" cy="5786102"/>
-          </a:xfrm>
-          <a:prstGeom prst="rect">
-            <a:avLst/>
-          </a:prstGeom>
-        </p:spPr>
-      </p:pic>
-    </p:spTree>
-    <p:extLst>
-      <p:ext uri="{BB962C8B-B14F-4D97-AF65-F5344CB8AC3E}">
-        <p14:creationId xmlns:p14="http://schemas.microsoft.com/office/powerpoint/2010/main" val="2024328479"/>
-      </p:ext>
-    </p:extLst>
-  </p:cSld>
-  <p:clrMapOvr>
-    <a:masterClrMapping/>
-  </p:clrMapOvr>
-</p:sld>
-</file>
-
-<file path=ppt/slides/slide14.xml><?xml version="1.0" encoding="utf-8"?>
-<p:sld xmlns:a="http://schemas.openxmlformats.org/drawingml/2006/main" xmlns:r="http://schemas.openxmlformats.org/officeDocument/2006/relationships" xmlns:p="http://schemas.openxmlformats.org/presentationml/2006/main">
-  <p:cSld>
-    <p:spTree>
-      <p:nvGrpSpPr>
-        <p:cNvPr id="1" name="">
-          <a:extLst>
-            <a:ext uri="{FF2B5EF4-FFF2-40B4-BE49-F238E27FC236}">
-              <a16:creationId xmlns:a16="http://schemas.microsoft.com/office/drawing/2014/main" id="{BA3FE163-3652-8D85-7226-16BF78E94D3B}"/>
-            </a:ext>
-          </a:extLst>
-        </p:cNvPr>
-        <p:cNvGrpSpPr/>
-        <p:nvPr/>
-      </p:nvGrpSpPr>
-      <p:grpSpPr>
-        <a:xfrm>
-          <a:off x="0" y="0"/>
-          <a:ext cx="0" cy="0"/>
-          <a:chOff x="0" y="0"/>
-          <a:chExt cx="0" cy="0"/>
-        </a:xfrm>
-      </p:grpSpPr>
-      <p:sp>
-        <p:nvSpPr>
-          <p:cNvPr id="4" name="Title 3">
-            <a:extLst>
-              <a:ext uri="{FF2B5EF4-FFF2-40B4-BE49-F238E27FC236}">
-                <a16:creationId xmlns:a16="http://schemas.microsoft.com/office/drawing/2014/main" id="{933E5EC4-F47F-D7DB-6D35-53F8B9280C63}"/>
-              </a:ext>
-            </a:extLst>
-          </p:cNvPr>
-          <p:cNvSpPr>
-            <a:spLocks noGrp="1"/>
-          </p:cNvSpPr>
-          <p:nvPr>
-            <p:ph type="title"/>
-          </p:nvPr>
-        </p:nvSpPr>
-        <p:spPr>
-          <a:xfrm>
-            <a:off x="90948" y="67362"/>
-            <a:ext cx="10515600" cy="1325563"/>
-          </a:xfrm>
-        </p:spPr>
-        <p:txBody>
-          <a:bodyPr/>
-          <a:lstStyle/>
-          <a:p>
-            <a:r>
-              <a:rPr lang="en-US" dirty="0"/>
-              <a:t>LVNV, WT sirtalis, T, and WT </a:t>
-            </a:r>
-            <a:r>
-              <a:rPr lang="en-US" dirty="0" err="1"/>
-              <a:t>hammondii</a:t>
-            </a:r>
-            <a:endParaRPr lang="en-US" dirty="0"/>
-          </a:p>
-        </p:txBody>
-      </p:sp>
-      <p:pic>
-        <p:nvPicPr>
-          <p:cNvPr id="14" name="Picture 13">
-            <a:extLst>
-              <a:ext uri="{FF2B5EF4-FFF2-40B4-BE49-F238E27FC236}">
-                <a16:creationId xmlns:a16="http://schemas.microsoft.com/office/drawing/2014/main" id="{B7A2896C-40EB-5300-6D87-E0679A1C4924}"/>
-              </a:ext>
-            </a:extLst>
-          </p:cNvPr>
-          <p:cNvPicPr>
-            <a:picLocks noChangeAspect="1"/>
-          </p:cNvPicPr>
-          <p:nvPr/>
-        </p:nvPicPr>
-        <p:blipFill>
-          <a:blip r:embed="rId3">
-            <a:extLst>
-              <a:ext uri="{28A0092B-C50C-407E-A947-70E740481C1C}">
-                <a14:useLocalDpi xmlns:a14="http://schemas.microsoft.com/office/drawing/2010/main" val="0"/>
-              </a:ext>
-            </a:extLst>
-          </a:blip>
-          <a:stretch>
-            <a:fillRect/>
-          </a:stretch>
-        </p:blipFill>
-        <p:spPr>
-          <a:xfrm>
-            <a:off x="2796533" y="1325563"/>
-            <a:ext cx="6598933" cy="5465075"/>
-          </a:xfrm>
-          <a:prstGeom prst="rect">
-            <a:avLst/>
-          </a:prstGeom>
-        </p:spPr>
-      </p:pic>
-    </p:spTree>
-    <p:extLst>
-      <p:ext uri="{BB962C8B-B14F-4D97-AF65-F5344CB8AC3E}">
-        <p14:creationId xmlns:p14="http://schemas.microsoft.com/office/powerpoint/2010/main" val="2130636375"/>
-      </p:ext>
-    </p:extLst>
-  </p:cSld>
-  <p:clrMapOvr>
-    <a:masterClrMapping/>
-  </p:clrMapOvr>
-</p:sld>
-</file>
-
-<file path=ppt/slides/slide15.xml><?xml version="1.0" encoding="utf-8"?>
-<p:sld xmlns:a="http://schemas.openxmlformats.org/drawingml/2006/main" xmlns:r="http://schemas.openxmlformats.org/officeDocument/2006/relationships" xmlns:p="http://schemas.openxmlformats.org/presentationml/2006/main">
-  <p:cSld>
-    <p:spTree>
-      <p:nvGrpSpPr>
-        <p:cNvPr id="1" name="">
-          <a:extLst>
-            <a:ext uri="{FF2B5EF4-FFF2-40B4-BE49-F238E27FC236}">
-              <a16:creationId xmlns:a16="http://schemas.microsoft.com/office/drawing/2014/main" id="{F001F2E3-B7FE-BC9A-D078-26F4DE252C7F}"/>
-            </a:ext>
-          </a:extLst>
-        </p:cNvPr>
-        <p:cNvGrpSpPr/>
-        <p:nvPr/>
-      </p:nvGrpSpPr>
-      <p:grpSpPr>
-        <a:xfrm>
-          <a:off x="0" y="0"/>
-          <a:ext cx="0" cy="0"/>
-          <a:chOff x="0" y="0"/>
-          <a:chExt cx="0" cy="0"/>
-        </a:xfrm>
-      </p:grpSpPr>
-      <p:pic>
-        <p:nvPicPr>
-          <p:cNvPr id="8" name="Picture 7">
-            <a:extLst>
-              <a:ext uri="{FF2B5EF4-FFF2-40B4-BE49-F238E27FC236}">
-                <a16:creationId xmlns:a16="http://schemas.microsoft.com/office/drawing/2014/main" id="{38A6683D-0A4C-6246-BAEE-57F47B38BC00}"/>
-              </a:ext>
-            </a:extLst>
-          </p:cNvPr>
-          <p:cNvPicPr>
-            <a:picLocks noChangeAspect="1"/>
-          </p:cNvPicPr>
-          <p:nvPr/>
-        </p:nvPicPr>
-        <p:blipFill>
-          <a:blip r:embed="rId3">
-            <a:extLst>
-              <a:ext uri="{28A0092B-C50C-407E-A947-70E740481C1C}">
-                <a14:useLocalDpi xmlns:a14="http://schemas.microsoft.com/office/drawing/2010/main" val="0"/>
-              </a:ext>
-            </a:extLst>
-          </a:blip>
-          <a:stretch>
-            <a:fillRect/>
-          </a:stretch>
-        </p:blipFill>
-        <p:spPr>
-          <a:xfrm>
-            <a:off x="2425422" y="1016982"/>
-            <a:ext cx="7052874" cy="5841018"/>
-          </a:xfrm>
-          <a:prstGeom prst="rect">
-            <a:avLst/>
-          </a:prstGeom>
-        </p:spPr>
-      </p:pic>
-      <p:sp>
-        <p:nvSpPr>
-          <p:cNvPr id="2" name="Title 3">
-            <a:extLst>
-              <a:ext uri="{FF2B5EF4-FFF2-40B4-BE49-F238E27FC236}">
-                <a16:creationId xmlns:a16="http://schemas.microsoft.com/office/drawing/2014/main" id="{0F526DD4-1F02-90A2-21E1-F5ED9FF065F5}"/>
-              </a:ext>
-            </a:extLst>
-          </p:cNvPr>
-          <p:cNvSpPr txBox="1">
-            <a:spLocks/>
-          </p:cNvSpPr>
-          <p:nvPr/>
-        </p:nvSpPr>
-        <p:spPr>
-          <a:xfrm>
-            <a:off x="90948" y="67362"/>
-            <a:ext cx="10515600" cy="1325563"/>
-          </a:xfrm>
-          <a:prstGeom prst="rect">
-            <a:avLst/>
-          </a:prstGeom>
-        </p:spPr>
-        <p:txBody>
-          <a:bodyPr vert="horz" lIns="91440" tIns="45720" rIns="91440" bIns="45720" rtlCol="0" anchor="ctr">
-            <a:normAutofit/>
-          </a:bodyPr>
-          <a:lstStyle>
-            <a:lvl1pPr algn="l" defTabSz="914400" rtl="0" eaLnBrk="1" latinLnBrk="0" hangingPunct="1">
-              <a:lnSpc>
-                <a:spcPct val="90000"/>
-              </a:lnSpc>
-              <a:spcBef>
-                <a:spcPct val="0"/>
-              </a:spcBef>
-              <a:buNone/>
-              <a:defRPr sz="4400" kern="1200">
-                <a:solidFill>
-                  <a:schemeClr val="tx1"/>
-                </a:solidFill>
-                <a:latin typeface="+mj-lt"/>
-                <a:ea typeface="+mj-ea"/>
-                <a:cs typeface="+mj-cs"/>
-              </a:defRPr>
-            </a:lvl1pPr>
-          </a:lstStyle>
-          <a:p>
-            <a:r>
-              <a:rPr lang="en-US"/>
-              <a:t>LVNV, WT sirtalis, T, and WT hammondii</a:t>
-            </a:r>
-            <a:endParaRPr lang="en-US" dirty="0"/>
-          </a:p>
-        </p:txBody>
-      </p:sp>
-    </p:spTree>
-    <p:extLst>
-      <p:ext uri="{BB962C8B-B14F-4D97-AF65-F5344CB8AC3E}">
-        <p14:creationId xmlns:p14="http://schemas.microsoft.com/office/powerpoint/2010/main" val="2730062183"/>
-      </p:ext>
-    </p:extLst>
-  </p:cSld>
-  <p:clrMapOvr>
-    <a:masterClrMapping/>
-  </p:clrMapOvr>
-</p:sld>
-</file>
-
-<file path=ppt/slides/slide16.xml><?xml version="1.0" encoding="utf-8"?>
-<p:sld xmlns:a="http://schemas.openxmlformats.org/drawingml/2006/main" xmlns:r="http://schemas.openxmlformats.org/officeDocument/2006/relationships" xmlns:p="http://schemas.openxmlformats.org/presentationml/2006/main">
-  <p:cSld>
-    <p:spTree>
-      <p:nvGrpSpPr>
-        <p:cNvPr id="1" name="">
-          <a:extLst>
-            <a:ext uri="{FF2B5EF4-FFF2-40B4-BE49-F238E27FC236}">
-              <a16:creationId xmlns:a16="http://schemas.microsoft.com/office/drawing/2014/main" id="{4460BEC3-72FD-0E53-909F-5F535746AA26}"/>
-            </a:ext>
-          </a:extLst>
-        </p:cNvPr>
-        <p:cNvGrpSpPr/>
-        <p:nvPr/>
-      </p:nvGrpSpPr>
-      <p:grpSpPr>
-        <a:xfrm>
-          <a:off x="0" y="0"/>
-          <a:ext cx="0" cy="0"/>
-          <a:chOff x="0" y="0"/>
-          <a:chExt cx="0" cy="0"/>
-        </a:xfrm>
-      </p:grpSpPr>
-      <p:pic>
-        <p:nvPicPr>
-          <p:cNvPr id="10" name="Picture 9">
-            <a:extLst>
-              <a:ext uri="{FF2B5EF4-FFF2-40B4-BE49-F238E27FC236}">
-                <a16:creationId xmlns:a16="http://schemas.microsoft.com/office/drawing/2014/main" id="{B8DFD697-9042-586E-5236-022A5816D0AB}"/>
-              </a:ext>
-            </a:extLst>
-          </p:cNvPr>
-          <p:cNvPicPr>
-            <a:picLocks noChangeAspect="1"/>
-          </p:cNvPicPr>
-          <p:nvPr/>
-        </p:nvPicPr>
-        <p:blipFill>
-          <a:blip r:embed="rId3">
-            <a:extLst>
-              <a:ext uri="{28A0092B-C50C-407E-A947-70E740481C1C}">
-                <a14:useLocalDpi xmlns:a14="http://schemas.microsoft.com/office/drawing/2010/main" val="0"/>
-              </a:ext>
-            </a:extLst>
-          </a:blip>
-          <a:stretch>
-            <a:fillRect/>
-          </a:stretch>
-        </p:blipFill>
-        <p:spPr>
-          <a:xfrm>
-            <a:off x="2870391" y="1124280"/>
-            <a:ext cx="6598933" cy="5465075"/>
-          </a:xfrm>
-          <a:prstGeom prst="rect">
-            <a:avLst/>
-          </a:prstGeom>
-        </p:spPr>
-      </p:pic>
-      <p:sp>
-        <p:nvSpPr>
-          <p:cNvPr id="2" name="Title 3">
-            <a:extLst>
-              <a:ext uri="{FF2B5EF4-FFF2-40B4-BE49-F238E27FC236}">
-                <a16:creationId xmlns:a16="http://schemas.microsoft.com/office/drawing/2014/main" id="{F513DE2B-F1AD-A55F-C524-CAAE9815B878}"/>
-              </a:ext>
-            </a:extLst>
-          </p:cNvPr>
-          <p:cNvSpPr txBox="1">
-            <a:spLocks/>
-          </p:cNvSpPr>
-          <p:nvPr/>
-        </p:nvSpPr>
-        <p:spPr>
-          <a:xfrm>
-            <a:off x="90948" y="67362"/>
-            <a:ext cx="10515600" cy="1325563"/>
-          </a:xfrm>
-          <a:prstGeom prst="rect">
-            <a:avLst/>
-          </a:prstGeom>
-        </p:spPr>
-        <p:txBody>
-          <a:bodyPr vert="horz" lIns="91440" tIns="45720" rIns="91440" bIns="45720" rtlCol="0" anchor="ctr">
-            <a:normAutofit/>
-          </a:bodyPr>
-          <a:lstStyle>
-            <a:lvl1pPr algn="l" defTabSz="914400" rtl="0" eaLnBrk="1" latinLnBrk="0" hangingPunct="1">
-              <a:lnSpc>
-                <a:spcPct val="90000"/>
-              </a:lnSpc>
-              <a:spcBef>
-                <a:spcPct val="0"/>
-              </a:spcBef>
-              <a:buNone/>
-              <a:defRPr sz="4400" kern="1200">
-                <a:solidFill>
-                  <a:schemeClr val="tx1"/>
-                </a:solidFill>
-                <a:latin typeface="+mj-lt"/>
-                <a:ea typeface="+mj-ea"/>
-                <a:cs typeface="+mj-cs"/>
-              </a:defRPr>
-            </a:lvl1pPr>
-          </a:lstStyle>
-          <a:p>
-            <a:r>
-              <a:rPr lang="en-US"/>
-              <a:t>LVNV, WT sirtalis, T, and WT hammondii</a:t>
-            </a:r>
-            <a:endParaRPr lang="en-US" dirty="0"/>
-          </a:p>
-        </p:txBody>
-      </p:sp>
-    </p:spTree>
-    <p:extLst>
-      <p:ext uri="{BB962C8B-B14F-4D97-AF65-F5344CB8AC3E}">
-        <p14:creationId xmlns:p14="http://schemas.microsoft.com/office/powerpoint/2010/main" val="4275669859"/>
-      </p:ext>
-    </p:extLst>
-  </p:cSld>
-  <p:clrMapOvr>
-    <a:masterClrMapping/>
-  </p:clrMapOvr>
-</p:sld>
-</file>
-
-<file path=ppt/slides/slide17.xml><?xml version="1.0" encoding="utf-8"?>
-<p:sld xmlns:a="http://schemas.openxmlformats.org/drawingml/2006/main" xmlns:r="http://schemas.openxmlformats.org/officeDocument/2006/relationships" xmlns:p="http://schemas.openxmlformats.org/presentationml/2006/main">
-  <p:cSld>
-    <p:spTree>
-      <p:nvGrpSpPr>
-        <p:cNvPr id="1" name="">
-          <a:extLst>
-            <a:ext uri="{FF2B5EF4-FFF2-40B4-BE49-F238E27FC236}">
-              <a16:creationId xmlns:a16="http://schemas.microsoft.com/office/drawing/2014/main" id="{C1043B44-34D3-19EA-DD84-E70773487328}"/>
-            </a:ext>
-          </a:extLst>
-        </p:cNvPr>
-        <p:cNvGrpSpPr/>
-        <p:nvPr/>
-      </p:nvGrpSpPr>
-      <p:grpSpPr>
-        <a:xfrm>
-          <a:off x="0" y="0"/>
-          <a:ext cx="0" cy="0"/>
-          <a:chOff x="0" y="0"/>
-          <a:chExt cx="0" cy="0"/>
-        </a:xfrm>
-      </p:grpSpPr>
-      <p:pic>
-        <p:nvPicPr>
-          <p:cNvPr id="12" name="Picture 11">
-            <a:extLst>
-              <a:ext uri="{FF2B5EF4-FFF2-40B4-BE49-F238E27FC236}">
-                <a16:creationId xmlns:a16="http://schemas.microsoft.com/office/drawing/2014/main" id="{584685CD-EDF6-07EE-727F-E35EC68EA9F1}"/>
-              </a:ext>
-            </a:extLst>
-          </p:cNvPr>
-          <p:cNvPicPr>
-            <a:picLocks noChangeAspect="1"/>
-          </p:cNvPicPr>
-          <p:nvPr/>
-        </p:nvPicPr>
-        <p:blipFill>
-          <a:blip r:embed="rId3">
-            <a:extLst>
-              <a:ext uri="{28A0092B-C50C-407E-A947-70E740481C1C}">
-                <a14:useLocalDpi xmlns:a14="http://schemas.microsoft.com/office/drawing/2010/main" val="0"/>
-              </a:ext>
-            </a:extLst>
-          </a:blip>
-          <a:stretch>
-            <a:fillRect/>
-          </a:stretch>
-        </p:blipFill>
-        <p:spPr>
-          <a:xfrm>
-            <a:off x="2912236" y="1116036"/>
-            <a:ext cx="6598933" cy="5465075"/>
-          </a:xfrm>
-          <a:prstGeom prst="rect">
-            <a:avLst/>
-          </a:prstGeom>
-        </p:spPr>
-      </p:pic>
-      <p:sp>
-        <p:nvSpPr>
-          <p:cNvPr id="2" name="Title 3">
-            <a:extLst>
-              <a:ext uri="{FF2B5EF4-FFF2-40B4-BE49-F238E27FC236}">
-                <a16:creationId xmlns:a16="http://schemas.microsoft.com/office/drawing/2014/main" id="{A5044021-225C-787E-D993-31352B208DBF}"/>
-              </a:ext>
-            </a:extLst>
-          </p:cNvPr>
-          <p:cNvSpPr txBox="1">
-            <a:spLocks/>
-          </p:cNvSpPr>
-          <p:nvPr/>
-        </p:nvSpPr>
-        <p:spPr>
-          <a:xfrm>
-            <a:off x="90948" y="67362"/>
-            <a:ext cx="10515600" cy="1325563"/>
-          </a:xfrm>
-          <a:prstGeom prst="rect">
-            <a:avLst/>
-          </a:prstGeom>
-        </p:spPr>
-        <p:txBody>
-          <a:bodyPr vert="horz" lIns="91440" tIns="45720" rIns="91440" bIns="45720" rtlCol="0" anchor="ctr">
-            <a:normAutofit/>
-          </a:bodyPr>
-          <a:lstStyle>
-            <a:lvl1pPr algn="l" defTabSz="914400" rtl="0" eaLnBrk="1" latinLnBrk="0" hangingPunct="1">
-              <a:lnSpc>
-                <a:spcPct val="90000"/>
-              </a:lnSpc>
-              <a:spcBef>
-                <a:spcPct val="0"/>
-              </a:spcBef>
-              <a:buNone/>
-              <a:defRPr sz="4400" kern="1200">
-                <a:solidFill>
-                  <a:schemeClr val="tx1"/>
-                </a:solidFill>
-                <a:latin typeface="+mj-lt"/>
-                <a:ea typeface="+mj-ea"/>
-                <a:cs typeface="+mj-cs"/>
-              </a:defRPr>
-            </a:lvl1pPr>
-          </a:lstStyle>
-          <a:p>
-            <a:r>
-              <a:rPr lang="en-US"/>
-              <a:t>LVNV, WT sirtalis, T, and WT hammondii</a:t>
-            </a:r>
-            <a:endParaRPr lang="en-US" dirty="0"/>
-          </a:p>
-        </p:txBody>
-      </p:sp>
-    </p:spTree>
-    <p:extLst>
-      <p:ext uri="{BB962C8B-B14F-4D97-AF65-F5344CB8AC3E}">
-        <p14:creationId xmlns:p14="http://schemas.microsoft.com/office/powerpoint/2010/main" val="1172107471"/>
-      </p:ext>
-    </p:extLst>
-  </p:cSld>
-  <p:clrMapOvr>
-    <a:masterClrMapping/>
-  </p:clrMapOvr>
-</p:sld>
-</file>
-
-<file path=ppt/slides/slide18.xml><?xml version="1.0" encoding="utf-8"?>
-<p:sld xmlns:a="http://schemas.openxmlformats.org/drawingml/2006/main" xmlns:r="http://schemas.openxmlformats.org/officeDocument/2006/relationships" xmlns:p="http://schemas.openxmlformats.org/presentationml/2006/main">
-  <p:cSld>
-    <p:spTree>
-      <p:nvGrpSpPr>
-        <p:cNvPr id="1" name=""/>
-        <p:cNvGrpSpPr/>
-        <p:nvPr/>
-      </p:nvGrpSpPr>
-      <p:grpSpPr>
-        <a:xfrm>
-          <a:off x="0" y="0"/>
-          <a:ext cx="0" cy="0"/>
-          <a:chOff x="0" y="0"/>
-          <a:chExt cx="0" cy="0"/>
-        </a:xfrm>
-      </p:grpSpPr>
-      <p:sp>
-        <p:nvSpPr>
-          <p:cNvPr id="3" name="Title 2">
-            <a:extLst>
-              <a:ext uri="{FF2B5EF4-FFF2-40B4-BE49-F238E27FC236}">
-                <a16:creationId xmlns:a16="http://schemas.microsoft.com/office/drawing/2014/main" id="{2E352018-A25E-B43D-5D53-3A06345616FE}"/>
-              </a:ext>
-            </a:extLst>
-          </p:cNvPr>
-          <p:cNvSpPr>
-            <a:spLocks noGrp="1"/>
-          </p:cNvSpPr>
-          <p:nvPr>
-            <p:ph type="title"/>
-          </p:nvPr>
-        </p:nvSpPr>
-        <p:spPr/>
-        <p:txBody>
-          <a:bodyPr/>
-          <a:lstStyle/>
-          <a:p>
-            <a:r>
-              <a:rPr lang="en-US" dirty="0"/>
-              <a:t>Rheobase protocol</a:t>
-            </a:r>
-          </a:p>
-        </p:txBody>
-      </p:sp>
-      <p:sp>
-        <p:nvSpPr>
-          <p:cNvPr id="4" name="Text Placeholder 3">
-            <a:extLst>
-              <a:ext uri="{FF2B5EF4-FFF2-40B4-BE49-F238E27FC236}">
-                <a16:creationId xmlns:a16="http://schemas.microsoft.com/office/drawing/2014/main" id="{B9F7088C-394E-DDDE-A7B3-3A0D1F4BD1B2}"/>
-              </a:ext>
-            </a:extLst>
-          </p:cNvPr>
-          <p:cNvSpPr>
-            <a:spLocks noGrp="1"/>
-          </p:cNvSpPr>
-          <p:nvPr>
-            <p:ph type="body" idx="1"/>
-          </p:nvPr>
-        </p:nvSpPr>
-        <p:spPr/>
-        <p:txBody>
-          <a:bodyPr>
-            <a:normAutofit fontScale="92500"/>
-          </a:bodyPr>
-          <a:lstStyle/>
-          <a:p>
-            <a:r>
-              <a:rPr lang="en-US" dirty="0"/>
-              <a:t>I did not get here because I was over-ambitious and also had to redo all the previous plots multiple times because of a series of silly errors but I will also have this before our next meeting (hopefully by the end of the week if you’re curious and want to see them sooner, we can probably meet via zoom while I’m gone if you want)</a:t>
-            </a:r>
-          </a:p>
-        </p:txBody>
-      </p:sp>
-    </p:spTree>
-    <p:extLst>
-      <p:ext uri="{BB962C8B-B14F-4D97-AF65-F5344CB8AC3E}">
-        <p14:creationId xmlns:p14="http://schemas.microsoft.com/office/powerpoint/2010/main" val="2411144924"/>
-      </p:ext>
-    </p:extLst>
-  </p:cSld>
-  <p:clrMapOvr>
-    <a:masterClrMapping/>
-  </p:clrMapOvr>
-</p:sld>
-</file>
-
-<file path=ppt/slides/slide2.xml><?xml version="1.0" encoding="utf-8"?>
-<p:sld xmlns:a="http://schemas.openxmlformats.org/drawingml/2006/main" xmlns:r="http://schemas.openxmlformats.org/officeDocument/2006/relationships" xmlns:p="http://schemas.openxmlformats.org/presentationml/2006/main">
-  <p:cSld>
-    <p:spTree>
-      <p:nvGrpSpPr>
-        <p:cNvPr id="1" name=""/>
-        <p:cNvGrpSpPr/>
-        <p:nvPr/>
-      </p:nvGrpSpPr>
-      <p:grpSpPr>
-        <a:xfrm>
-          <a:off x="0" y="0"/>
-          <a:ext cx="0" cy="0"/>
-          <a:chOff x="0" y="0"/>
-          <a:chExt cx="0" cy="0"/>
-        </a:xfrm>
-      </p:grpSpPr>
-      <p:sp>
-        <p:nvSpPr>
-          <p:cNvPr id="4" name="Title 3">
-            <a:extLst>
-              <a:ext uri="{FF2B5EF4-FFF2-40B4-BE49-F238E27FC236}">
-                <a16:creationId xmlns:a16="http://schemas.microsoft.com/office/drawing/2014/main" id="{3BB4873F-15A7-243F-3F5E-1339E0076EF6}"/>
-              </a:ext>
-            </a:extLst>
-          </p:cNvPr>
-          <p:cNvSpPr>
-            <a:spLocks noGrp="1"/>
-          </p:cNvSpPr>
-          <p:nvPr>
-            <p:ph type="title"/>
-          </p:nvPr>
-        </p:nvSpPr>
-        <p:spPr/>
-        <p:txBody>
-          <a:bodyPr/>
-          <a:lstStyle/>
-          <a:p>
-            <a:r>
-              <a:rPr lang="en-US" dirty="0"/>
-              <a:t>Transient contractions (C4P)</a:t>
-            </a:r>
-          </a:p>
-        </p:txBody>
-      </p:sp>
-      <p:sp>
-        <p:nvSpPr>
-          <p:cNvPr id="5" name="Text Placeholder 4">
-            <a:extLst>
-              <a:ext uri="{FF2B5EF4-FFF2-40B4-BE49-F238E27FC236}">
-                <a16:creationId xmlns:a16="http://schemas.microsoft.com/office/drawing/2014/main" id="{3879C9DE-A46A-AA88-41BA-2B9B8190A14C}"/>
-              </a:ext>
-            </a:extLst>
-          </p:cNvPr>
-          <p:cNvSpPr>
-            <a:spLocks noGrp="1"/>
-          </p:cNvSpPr>
-          <p:nvPr>
-            <p:ph type="body" idx="1"/>
-          </p:nvPr>
-        </p:nvSpPr>
-        <p:spPr/>
-        <p:txBody>
-          <a:bodyPr/>
-          <a:lstStyle/>
-          <a:p>
-            <a:r>
-              <a:rPr lang="en-US" dirty="0"/>
-              <a:t>I apologize that the genotype colors are inconsistent across plots, I realized this as I was putting it together and I don’t have time to fix it tonight but I will get it fixed by whenever we next meet</a:t>
-            </a:r>
-          </a:p>
-        </p:txBody>
-      </p:sp>
-    </p:spTree>
-    <p:extLst>
-      <p:ext uri="{BB962C8B-B14F-4D97-AF65-F5344CB8AC3E}">
-        <p14:creationId xmlns:p14="http://schemas.microsoft.com/office/powerpoint/2010/main" val="2886554321"/>
-      </p:ext>
-    </p:extLst>
-  </p:cSld>
-  <p:clrMapOvr>
-    <a:masterClrMapping/>
-  </p:clrMapOvr>
-</p:sld>
-</file>
-
-<file path=ppt/slides/slide3.xml><?xml version="1.0" encoding="utf-8"?>
-<p:sld xmlns:a="http://schemas.openxmlformats.org/drawingml/2006/main" xmlns:r="http://schemas.openxmlformats.org/officeDocument/2006/relationships" xmlns:p="http://schemas.openxmlformats.org/presentationml/2006/main">
-  <p:cSld>
-    <p:spTree>
-      <p:nvGrpSpPr>
-        <p:cNvPr id="1" name=""/>
-        <p:cNvGrpSpPr/>
-        <p:nvPr/>
-      </p:nvGrpSpPr>
-      <p:grpSpPr>
-        <a:xfrm>
-          <a:off x="0" y="0"/>
-          <a:ext cx="0" cy="0"/>
-          <a:chOff x="0" y="0"/>
-          <a:chExt cx="0" cy="0"/>
-        </a:xfrm>
-      </p:grpSpPr>
-      <p:pic>
-        <p:nvPicPr>
-          <p:cNvPr id="5" name="Picture 4">
-            <a:extLst>
-              <a:ext uri="{FF2B5EF4-FFF2-40B4-BE49-F238E27FC236}">
-                <a16:creationId xmlns:a16="http://schemas.microsoft.com/office/drawing/2014/main" id="{802CC107-9FFD-BBFB-A181-68528F936C36}"/>
-              </a:ext>
-            </a:extLst>
-          </p:cNvPr>
-          <p:cNvPicPr>
-            <a:picLocks noChangeAspect="1"/>
-          </p:cNvPicPr>
-          <p:nvPr/>
-        </p:nvPicPr>
-        <p:blipFill>
-          <a:blip r:embed="rId3">
-            <a:extLst>
-              <a:ext uri="{28A0092B-C50C-407E-A947-70E740481C1C}">
-                <a14:useLocalDpi xmlns:a14="http://schemas.microsoft.com/office/drawing/2010/main" val="0"/>
-              </a:ext>
-            </a:extLst>
-          </a:blip>
-          <a:stretch>
-            <a:fillRect/>
-          </a:stretch>
-        </p:blipFill>
-        <p:spPr>
-          <a:xfrm>
-            <a:off x="2116021" y="132879"/>
-            <a:ext cx="7959957" cy="6592242"/>
-          </a:xfrm>
-          <a:prstGeom prst="rect">
-            <a:avLst/>
-          </a:prstGeom>
-        </p:spPr>
-      </p:pic>
-    </p:spTree>
-    <p:extLst>
-      <p:ext uri="{BB962C8B-B14F-4D97-AF65-F5344CB8AC3E}">
-        <p14:creationId xmlns:p14="http://schemas.microsoft.com/office/powerpoint/2010/main" val="4208517190"/>
-      </p:ext>
-    </p:extLst>
-  </p:cSld>
-  <p:clrMapOvr>
-    <a:masterClrMapping/>
-  </p:clrMapOvr>
-</p:sld>
-</file>
-
-<file path=ppt/slides/slide4.xml><?xml version="1.0" encoding="utf-8"?>
-<p:sld xmlns:a="http://schemas.openxmlformats.org/drawingml/2006/main" xmlns:r="http://schemas.openxmlformats.org/officeDocument/2006/relationships" xmlns:p="http://schemas.openxmlformats.org/presentationml/2006/main">
-  <p:cSld>
-    <p:spTree>
-      <p:nvGrpSpPr>
-        <p:cNvPr id="1" name=""/>
-        <p:cNvGrpSpPr/>
-        <p:nvPr/>
-      </p:nvGrpSpPr>
-      <p:grpSpPr>
-        <a:xfrm>
-          <a:off x="0" y="0"/>
-          <a:ext cx="0" cy="0"/>
-          <a:chOff x="0" y="0"/>
-          <a:chExt cx="0" cy="0"/>
-        </a:xfrm>
-      </p:grpSpPr>
-      <p:pic>
-        <p:nvPicPr>
-          <p:cNvPr id="31" name="Picture 30">
-            <a:extLst>
-              <a:ext uri="{FF2B5EF4-FFF2-40B4-BE49-F238E27FC236}">
-                <a16:creationId xmlns:a16="http://schemas.microsoft.com/office/drawing/2014/main" id="{4F500660-B97C-7AFD-62DA-A418B27FFFE5}"/>
-              </a:ext>
-            </a:extLst>
-          </p:cNvPr>
-          <p:cNvPicPr>
-            <a:picLocks noChangeAspect="1"/>
-          </p:cNvPicPr>
-          <p:nvPr/>
-        </p:nvPicPr>
-        <p:blipFill>
-          <a:blip r:embed="rId3">
-            <a:extLst>
-              <a:ext uri="{28A0092B-C50C-407E-A947-70E740481C1C}">
-                <a14:useLocalDpi xmlns:a14="http://schemas.microsoft.com/office/drawing/2010/main" val="0"/>
-              </a:ext>
-            </a:extLst>
-          </a:blip>
-          <a:stretch>
-            <a:fillRect/>
-          </a:stretch>
-        </p:blipFill>
-        <p:spPr>
-          <a:xfrm>
-            <a:off x="2483125" y="580104"/>
-            <a:ext cx="7658370" cy="6342475"/>
-          </a:xfrm>
-          <a:prstGeom prst="rect">
-            <a:avLst/>
-          </a:prstGeom>
-        </p:spPr>
-      </p:pic>
-      <p:sp>
-        <p:nvSpPr>
-          <p:cNvPr id="2" name="Title 1">
-            <a:extLst>
-              <a:ext uri="{FF2B5EF4-FFF2-40B4-BE49-F238E27FC236}">
-                <a16:creationId xmlns:a16="http://schemas.microsoft.com/office/drawing/2014/main" id="{8CFE8FC2-74F4-9BB5-D225-735858BA7BC7}"/>
-              </a:ext>
-            </a:extLst>
-          </p:cNvPr>
-          <p:cNvSpPr>
-            <a:spLocks noGrp="1"/>
-          </p:cNvSpPr>
-          <p:nvPr>
-            <p:ph type="title"/>
-          </p:nvPr>
-        </p:nvSpPr>
-        <p:spPr>
-          <a:xfrm>
-            <a:off x="149942" y="156572"/>
-            <a:ext cx="6162368" cy="423532"/>
-          </a:xfrm>
-        </p:spPr>
-        <p:txBody>
-          <a:bodyPr>
-            <a:normAutofit fontScale="90000"/>
-          </a:bodyPr>
-          <a:lstStyle/>
-          <a:p>
-            <a:r>
-              <a:rPr lang="en-US" dirty="0"/>
-              <a:t>LVNV, T, WT sirtalis</a:t>
-            </a:r>
-          </a:p>
-        </p:txBody>
-      </p:sp>
-    </p:spTree>
-    <p:extLst>
-      <p:ext uri="{BB962C8B-B14F-4D97-AF65-F5344CB8AC3E}">
-        <p14:creationId xmlns:p14="http://schemas.microsoft.com/office/powerpoint/2010/main" val="3596044053"/>
-      </p:ext>
-    </p:extLst>
-  </p:cSld>
-  <p:clrMapOvr>
-    <a:masterClrMapping/>
-  </p:clrMapOvr>
-</p:sld>
-</file>
-
-<file path=ppt/slides/slide5.xml><?xml version="1.0" encoding="utf-8"?>
-<p:sld xmlns:a="http://schemas.openxmlformats.org/drawingml/2006/main" xmlns:r="http://schemas.openxmlformats.org/officeDocument/2006/relationships" xmlns:p="http://schemas.openxmlformats.org/presentationml/2006/main">
-  <p:cSld>
-    <p:spTree>
-      <p:nvGrpSpPr>
-        <p:cNvPr id="1" name=""/>
-        <p:cNvGrpSpPr/>
-        <p:nvPr/>
-      </p:nvGrpSpPr>
-      <p:grpSpPr>
-        <a:xfrm>
-          <a:off x="0" y="0"/>
-          <a:ext cx="0" cy="0"/>
-          <a:chOff x="0" y="0"/>
-          <a:chExt cx="0" cy="0"/>
-        </a:xfrm>
-      </p:grpSpPr>
-      <p:pic>
-        <p:nvPicPr>
-          <p:cNvPr id="29" name="Picture 28">
-            <a:extLst>
-              <a:ext uri="{FF2B5EF4-FFF2-40B4-BE49-F238E27FC236}">
-                <a16:creationId xmlns:a16="http://schemas.microsoft.com/office/drawing/2014/main" id="{2DBBFDC0-9179-B2DE-3509-8AABFAFBB859}"/>
-              </a:ext>
-            </a:extLst>
-          </p:cNvPr>
-          <p:cNvPicPr>
-            <a:picLocks noChangeAspect="1"/>
-          </p:cNvPicPr>
-          <p:nvPr/>
-        </p:nvPicPr>
-        <p:blipFill>
-          <a:blip r:embed="rId3">
-            <a:extLst>
-              <a:ext uri="{28A0092B-C50C-407E-A947-70E740481C1C}">
-                <a14:useLocalDpi xmlns:a14="http://schemas.microsoft.com/office/drawing/2010/main" val="0"/>
-              </a:ext>
-            </a:extLst>
-          </a:blip>
-          <a:stretch>
-            <a:fillRect/>
-          </a:stretch>
-        </p:blipFill>
-        <p:spPr>
-          <a:xfrm>
-            <a:off x="2470331" y="743132"/>
-            <a:ext cx="7251338" cy="6005381"/>
-          </a:xfrm>
-          <a:prstGeom prst="rect">
-            <a:avLst/>
-          </a:prstGeom>
-        </p:spPr>
-      </p:pic>
-      <p:sp>
-        <p:nvSpPr>
-          <p:cNvPr id="3" name="Title 2">
-            <a:extLst>
-              <a:ext uri="{FF2B5EF4-FFF2-40B4-BE49-F238E27FC236}">
-                <a16:creationId xmlns:a16="http://schemas.microsoft.com/office/drawing/2014/main" id="{1B066AFE-3330-875C-2992-77ECA537184C}"/>
-              </a:ext>
-            </a:extLst>
-          </p:cNvPr>
-          <p:cNvSpPr>
-            <a:spLocks noGrp="1"/>
-          </p:cNvSpPr>
-          <p:nvPr>
-            <p:ph type="title"/>
-          </p:nvPr>
-        </p:nvSpPr>
-        <p:spPr>
-          <a:xfrm>
-            <a:off x="130277" y="109487"/>
-            <a:ext cx="9869129" cy="667262"/>
-          </a:xfrm>
-        </p:spPr>
-        <p:txBody>
-          <a:bodyPr>
-            <a:normAutofit fontScale="90000"/>
-          </a:bodyPr>
-          <a:lstStyle/>
-          <a:p>
-            <a:r>
-              <a:rPr lang="en-US" dirty="0"/>
-              <a:t>EPN, LVNV, T, WT sirtalis</a:t>
-            </a:r>
-          </a:p>
-        </p:txBody>
-      </p:sp>
-    </p:spTree>
-    <p:extLst>
-      <p:ext uri="{BB962C8B-B14F-4D97-AF65-F5344CB8AC3E}">
-        <p14:creationId xmlns:p14="http://schemas.microsoft.com/office/powerpoint/2010/main" val="959217749"/>
-      </p:ext>
-    </p:extLst>
-  </p:cSld>
-  <p:clrMapOvr>
-    <a:masterClrMapping/>
-  </p:clrMapOvr>
-</p:sld>
-</file>
-
-<file path=ppt/slides/slide6.xml><?xml version="1.0" encoding="utf-8"?>
-<p:sld xmlns:a="http://schemas.openxmlformats.org/drawingml/2006/main" xmlns:r="http://schemas.openxmlformats.org/officeDocument/2006/relationships" xmlns:p="http://schemas.openxmlformats.org/presentationml/2006/main">
-  <p:cSld>
-    <p:spTree>
-      <p:nvGrpSpPr>
-        <p:cNvPr id="1" name=""/>
-        <p:cNvGrpSpPr/>
-        <p:nvPr/>
-      </p:nvGrpSpPr>
-      <p:grpSpPr>
-        <a:xfrm>
-          <a:off x="0" y="0"/>
-          <a:ext cx="0" cy="0"/>
-          <a:chOff x="0" y="0"/>
-          <a:chExt cx="0" cy="0"/>
-        </a:xfrm>
-      </p:grpSpPr>
-      <p:pic>
-        <p:nvPicPr>
-          <p:cNvPr id="21" name="Picture 20">
-            <a:extLst>
-              <a:ext uri="{FF2B5EF4-FFF2-40B4-BE49-F238E27FC236}">
-                <a16:creationId xmlns:a16="http://schemas.microsoft.com/office/drawing/2014/main" id="{ABBD96AC-A510-4B21-1CAD-CD4AA3181743}"/>
-              </a:ext>
-            </a:extLst>
-          </p:cNvPr>
-          <p:cNvPicPr>
-            <a:picLocks noChangeAspect="1"/>
-          </p:cNvPicPr>
-          <p:nvPr/>
-        </p:nvPicPr>
-        <p:blipFill>
-          <a:blip r:embed="rId3">
-            <a:extLst>
-              <a:ext uri="{28A0092B-C50C-407E-A947-70E740481C1C}">
-                <a14:useLocalDpi xmlns:a14="http://schemas.microsoft.com/office/drawing/2010/main" val="0"/>
-              </a:ext>
-            </a:extLst>
-          </a:blip>
-          <a:stretch>
-            <a:fillRect/>
-          </a:stretch>
-        </p:blipFill>
-        <p:spPr>
-          <a:xfrm>
-            <a:off x="2273570" y="597654"/>
-            <a:ext cx="7644860" cy="6331286"/>
-          </a:xfrm>
-          <a:prstGeom prst="rect">
-            <a:avLst/>
-          </a:prstGeom>
-        </p:spPr>
-      </p:pic>
-      <p:sp>
-        <p:nvSpPr>
-          <p:cNvPr id="2" name="Title 1">
-            <a:extLst>
-              <a:ext uri="{FF2B5EF4-FFF2-40B4-BE49-F238E27FC236}">
-                <a16:creationId xmlns:a16="http://schemas.microsoft.com/office/drawing/2014/main" id="{9E1B3FD0-DCB1-7C76-EB70-5B896BA4D7A4}"/>
-              </a:ext>
-            </a:extLst>
-          </p:cNvPr>
-          <p:cNvSpPr>
-            <a:spLocks noGrp="1"/>
-          </p:cNvSpPr>
-          <p:nvPr>
-            <p:ph type="title"/>
-          </p:nvPr>
-        </p:nvSpPr>
-        <p:spPr>
-          <a:xfrm>
-            <a:off x="159774" y="263357"/>
-            <a:ext cx="9080230" cy="175649"/>
-          </a:xfrm>
-        </p:spPr>
-        <p:txBody>
-          <a:bodyPr>
-            <a:normAutofit fontScale="90000"/>
-          </a:bodyPr>
-          <a:lstStyle/>
-          <a:p>
-            <a:r>
-              <a:rPr lang="en-US" dirty="0"/>
-              <a:t>T, LVNV, WT sirtalis, </a:t>
-            </a:r>
-            <a:r>
-              <a:rPr lang="en-US" dirty="0" err="1"/>
-              <a:t>hammondii</a:t>
-            </a:r>
-            <a:endParaRPr lang="en-US" dirty="0"/>
-          </a:p>
-        </p:txBody>
-      </p:sp>
-    </p:spTree>
-    <p:extLst>
-      <p:ext uri="{BB962C8B-B14F-4D97-AF65-F5344CB8AC3E}">
-        <p14:creationId xmlns:p14="http://schemas.microsoft.com/office/powerpoint/2010/main" val="3843965665"/>
-      </p:ext>
-    </p:extLst>
-  </p:cSld>
-  <p:clrMapOvr>
-    <a:masterClrMapping/>
-  </p:clrMapOvr>
-</p:sld>
-</file>
-
-<file path=ppt/slides/slide7.xml><?xml version="1.0" encoding="utf-8"?>
-<p:sld xmlns:a="http://schemas.openxmlformats.org/drawingml/2006/main" xmlns:r="http://schemas.openxmlformats.org/officeDocument/2006/relationships" xmlns:p="http://schemas.openxmlformats.org/presentationml/2006/main">
-  <p:cSld>
-    <p:spTree>
-      <p:nvGrpSpPr>
-        <p:cNvPr id="1" name=""/>
-        <p:cNvGrpSpPr/>
-        <p:nvPr/>
-      </p:nvGrpSpPr>
-      <p:grpSpPr>
-        <a:xfrm>
-          <a:off x="0" y="0"/>
-          <a:ext cx="0" cy="0"/>
-          <a:chOff x="0" y="0"/>
-          <a:chExt cx="0" cy="0"/>
-        </a:xfrm>
-      </p:grpSpPr>
-      <p:pic>
-        <p:nvPicPr>
-          <p:cNvPr id="23" name="Picture 22">
-            <a:extLst>
-              <a:ext uri="{FF2B5EF4-FFF2-40B4-BE49-F238E27FC236}">
-                <a16:creationId xmlns:a16="http://schemas.microsoft.com/office/drawing/2014/main" id="{20FF2F85-7B1C-51EB-2A21-E2C82DD1DB61}"/>
-              </a:ext>
-            </a:extLst>
-          </p:cNvPr>
-          <p:cNvPicPr>
-            <a:picLocks noChangeAspect="1"/>
-          </p:cNvPicPr>
-          <p:nvPr/>
-        </p:nvPicPr>
-        <p:blipFill>
-          <a:blip r:embed="rId3">
-            <a:extLst>
-              <a:ext uri="{28A0092B-C50C-407E-A947-70E740481C1C}">
-                <a14:useLocalDpi xmlns:a14="http://schemas.microsoft.com/office/drawing/2010/main" val="0"/>
-              </a:ext>
-            </a:extLst>
-          </a:blip>
-          <a:stretch>
-            <a:fillRect/>
-          </a:stretch>
-        </p:blipFill>
-        <p:spPr>
-          <a:xfrm>
-            <a:off x="2191850" y="529312"/>
-            <a:ext cx="7808299" cy="6466642"/>
-          </a:xfrm>
-          <a:prstGeom prst="rect">
-            <a:avLst/>
-          </a:prstGeom>
-        </p:spPr>
-      </p:pic>
-      <p:pic>
-        <p:nvPicPr>
-          <p:cNvPr id="4" name="Picture 3">
-            <a:extLst>
-              <a:ext uri="{FF2B5EF4-FFF2-40B4-BE49-F238E27FC236}">
-                <a16:creationId xmlns:a16="http://schemas.microsoft.com/office/drawing/2014/main" id="{B11CAAF9-DF87-20B5-B87E-C1F8AE1B399C}"/>
-              </a:ext>
-            </a:extLst>
-          </p:cNvPr>
-          <p:cNvPicPr>
-            <a:picLocks noChangeAspect="1"/>
-          </p:cNvPicPr>
-          <p:nvPr/>
-        </p:nvPicPr>
-        <p:blipFill>
-          <a:blip r:embed="rId4"/>
-          <a:stretch>
-            <a:fillRect/>
-          </a:stretch>
-        </p:blipFill>
-        <p:spPr>
-          <a:xfrm>
-            <a:off x="-165093" y="-86075"/>
-            <a:ext cx="9297206" cy="1072989"/>
-          </a:xfrm>
-          <a:prstGeom prst="rect">
-            <a:avLst/>
-          </a:prstGeom>
-        </p:spPr>
-      </p:pic>
-    </p:spTree>
-    <p:extLst>
-      <p:ext uri="{BB962C8B-B14F-4D97-AF65-F5344CB8AC3E}">
-        <p14:creationId xmlns:p14="http://schemas.microsoft.com/office/powerpoint/2010/main" val="692453888"/>
-      </p:ext>
-    </p:extLst>
-  </p:cSld>
-  <p:clrMapOvr>
-    <a:masterClrMapping/>
-  </p:clrMapOvr>
-</p:sld>
-</file>
-
-<file path=ppt/slides/slide8.xml><?xml version="1.0" encoding="utf-8"?>
-<p:sld xmlns:a="http://schemas.openxmlformats.org/drawingml/2006/main" xmlns:r="http://schemas.openxmlformats.org/officeDocument/2006/relationships" xmlns:p="http://schemas.openxmlformats.org/presentationml/2006/main">
-  <p:cSld>
-    <p:spTree>
-      <p:nvGrpSpPr>
         <p:cNvPr id="1" name="">
           <a:extLst>
             <a:ext uri="{FF2B5EF4-FFF2-40B4-BE49-F238E27FC236}">
@@ -6639,7 +5151,7 @@
 </p:sld>
 </file>
 
-<file path=ppt/slides/slide9.xml><?xml version="1.0" encoding="utf-8"?>
+<file path=ppt/slides/slide11.xml><?xml version="1.0" encoding="utf-8"?>
 <p:sld xmlns:a="http://schemas.openxmlformats.org/drawingml/2006/main" xmlns:r="http://schemas.openxmlformats.org/officeDocument/2006/relationships" xmlns:p="http://schemas.openxmlformats.org/presentationml/2006/main">
   <p:cSld>
     <p:spTree>
@@ -6732,6 +5244,1998 @@
     <p:extLst>
       <p:ext uri="{BB962C8B-B14F-4D97-AF65-F5344CB8AC3E}">
         <p14:creationId xmlns:p14="http://schemas.microsoft.com/office/powerpoint/2010/main" val="1751170841"/>
+      </p:ext>
+    </p:extLst>
+  </p:cSld>
+  <p:clrMapOvr>
+    <a:masterClrMapping/>
+  </p:clrMapOvr>
+</p:sld>
+</file>
+
+<file path=ppt/slides/slide12.xml><?xml version="1.0" encoding="utf-8"?>
+<p:sld xmlns:a="http://schemas.openxmlformats.org/drawingml/2006/main" xmlns:r="http://schemas.openxmlformats.org/officeDocument/2006/relationships" xmlns:p="http://schemas.openxmlformats.org/presentationml/2006/main">
+  <p:cSld>
+    <p:spTree>
+      <p:nvGrpSpPr>
+        <p:cNvPr id="1" name=""/>
+        <p:cNvGrpSpPr/>
+        <p:nvPr/>
+      </p:nvGrpSpPr>
+      <p:grpSpPr>
+        <a:xfrm>
+          <a:off x="0" y="0"/>
+          <a:ext cx="0" cy="0"/>
+          <a:chOff x="0" y="0"/>
+          <a:chExt cx="0" cy="0"/>
+        </a:xfrm>
+      </p:grpSpPr>
+      <p:sp>
+        <p:nvSpPr>
+          <p:cNvPr id="2" name="Title 1">
+            <a:extLst>
+              <a:ext uri="{FF2B5EF4-FFF2-40B4-BE49-F238E27FC236}">
+                <a16:creationId xmlns:a16="http://schemas.microsoft.com/office/drawing/2014/main" id="{F22E7229-A7F7-248B-E6F8-BE83DB34ADB7}"/>
+              </a:ext>
+            </a:extLst>
+          </p:cNvPr>
+          <p:cNvSpPr>
+            <a:spLocks noGrp="1"/>
+          </p:cNvSpPr>
+          <p:nvPr>
+            <p:ph type="title"/>
+          </p:nvPr>
+        </p:nvSpPr>
+        <p:spPr/>
+        <p:txBody>
+          <a:bodyPr/>
+          <a:lstStyle/>
+          <a:p>
+            <a:r>
+              <a:rPr lang="en-US" dirty="0"/>
+              <a:t>Tetanic contractions (tetanus)</a:t>
+            </a:r>
+          </a:p>
+        </p:txBody>
+      </p:sp>
+      <p:sp>
+        <p:nvSpPr>
+          <p:cNvPr id="3" name="Text Placeholder 2">
+            <a:extLst>
+              <a:ext uri="{FF2B5EF4-FFF2-40B4-BE49-F238E27FC236}">
+                <a16:creationId xmlns:a16="http://schemas.microsoft.com/office/drawing/2014/main" id="{3A446006-E94C-5109-981F-0EE1E9215759}"/>
+              </a:ext>
+            </a:extLst>
+          </p:cNvPr>
+          <p:cNvSpPr>
+            <a:spLocks noGrp="1"/>
+          </p:cNvSpPr>
+          <p:nvPr>
+            <p:ph type="body" idx="1"/>
+          </p:nvPr>
+        </p:nvSpPr>
+        <p:spPr/>
+        <p:txBody>
+          <a:bodyPr/>
+          <a:lstStyle/>
+          <a:p>
+            <a:r>
+              <a:rPr lang="en-US" dirty="0"/>
+              <a:t>Same note about the colors, apologies that they’re all wonky again</a:t>
+            </a:r>
+          </a:p>
+        </p:txBody>
+      </p:sp>
+    </p:spTree>
+    <p:extLst>
+      <p:ext uri="{BB962C8B-B14F-4D97-AF65-F5344CB8AC3E}">
+        <p14:creationId xmlns:p14="http://schemas.microsoft.com/office/powerpoint/2010/main" val="1388248658"/>
+      </p:ext>
+    </p:extLst>
+  </p:cSld>
+  <p:clrMapOvr>
+    <a:masterClrMapping/>
+  </p:clrMapOvr>
+</p:sld>
+</file>
+
+<file path=ppt/slides/slide13.xml><?xml version="1.0" encoding="utf-8"?>
+<p:sld xmlns:a="http://schemas.openxmlformats.org/drawingml/2006/main" xmlns:r="http://schemas.openxmlformats.org/officeDocument/2006/relationships" xmlns:p="http://schemas.openxmlformats.org/presentationml/2006/main">
+  <p:cSld>
+    <p:spTree>
+      <p:nvGrpSpPr>
+        <p:cNvPr id="1" name=""/>
+        <p:cNvGrpSpPr/>
+        <p:nvPr/>
+      </p:nvGrpSpPr>
+      <p:grpSpPr>
+        <a:xfrm>
+          <a:off x="0" y="0"/>
+          <a:ext cx="0" cy="0"/>
+          <a:chOff x="0" y="0"/>
+          <a:chExt cx="0" cy="0"/>
+        </a:xfrm>
+      </p:grpSpPr>
+      <p:sp>
+        <p:nvSpPr>
+          <p:cNvPr id="4" name="Title 3">
+            <a:extLst>
+              <a:ext uri="{FF2B5EF4-FFF2-40B4-BE49-F238E27FC236}">
+                <a16:creationId xmlns:a16="http://schemas.microsoft.com/office/drawing/2014/main" id="{C621FD58-D8DF-4216-E79C-69D541F9DF72}"/>
+              </a:ext>
+            </a:extLst>
+          </p:cNvPr>
+          <p:cNvSpPr>
+            <a:spLocks noGrp="1"/>
+          </p:cNvSpPr>
+          <p:nvPr>
+            <p:ph type="title"/>
+          </p:nvPr>
+        </p:nvSpPr>
+        <p:spPr>
+          <a:xfrm>
+            <a:off x="237066" y="-146756"/>
+            <a:ext cx="10515600" cy="1325563"/>
+          </a:xfrm>
+        </p:spPr>
+        <p:txBody>
+          <a:bodyPr/>
+          <a:lstStyle/>
+          <a:p>
+            <a:r>
+              <a:rPr lang="en-US" dirty="0"/>
+              <a:t>All</a:t>
+            </a:r>
+          </a:p>
+        </p:txBody>
+      </p:sp>
+      <p:pic>
+        <p:nvPicPr>
+          <p:cNvPr id="6" name="Picture 5">
+            <a:extLst>
+              <a:ext uri="{FF2B5EF4-FFF2-40B4-BE49-F238E27FC236}">
+                <a16:creationId xmlns:a16="http://schemas.microsoft.com/office/drawing/2014/main" id="{9CDB7DB8-A0FB-BC8E-495F-4BDABE32916F}"/>
+              </a:ext>
+            </a:extLst>
+          </p:cNvPr>
+          <p:cNvPicPr>
+            <a:picLocks noChangeAspect="1"/>
+          </p:cNvPicPr>
+          <p:nvPr/>
+        </p:nvPicPr>
+        <p:blipFill>
+          <a:blip r:embed="rId2">
+            <a:extLst>
+              <a:ext uri="{28A0092B-C50C-407E-A947-70E740481C1C}">
+                <a14:useLocalDpi xmlns:a14="http://schemas.microsoft.com/office/drawing/2010/main" val="0"/>
+              </a:ext>
+            </a:extLst>
+          </a:blip>
+          <a:stretch>
+            <a:fillRect/>
+          </a:stretch>
+        </p:blipFill>
+        <p:spPr>
+          <a:xfrm>
+            <a:off x="2310830" y="777857"/>
+            <a:ext cx="8616814" cy="5913132"/>
+          </a:xfrm>
+          <a:prstGeom prst="rect">
+            <a:avLst/>
+          </a:prstGeom>
+        </p:spPr>
+      </p:pic>
+    </p:spTree>
+    <p:extLst>
+      <p:ext uri="{BB962C8B-B14F-4D97-AF65-F5344CB8AC3E}">
+        <p14:creationId xmlns:p14="http://schemas.microsoft.com/office/powerpoint/2010/main" val="3292886314"/>
+      </p:ext>
+    </p:extLst>
+  </p:cSld>
+  <p:clrMapOvr>
+    <a:masterClrMapping/>
+  </p:clrMapOvr>
+</p:sld>
+</file>
+
+<file path=ppt/slides/slide14.xml><?xml version="1.0" encoding="utf-8"?>
+<p:sld xmlns:a="http://schemas.openxmlformats.org/drawingml/2006/main" xmlns:r="http://schemas.openxmlformats.org/officeDocument/2006/relationships" xmlns:p="http://schemas.openxmlformats.org/presentationml/2006/main">
+  <p:cSld>
+    <p:spTree>
+      <p:nvGrpSpPr>
+        <p:cNvPr id="1" name=""/>
+        <p:cNvGrpSpPr/>
+        <p:nvPr/>
+      </p:nvGrpSpPr>
+      <p:grpSpPr>
+        <a:xfrm>
+          <a:off x="0" y="0"/>
+          <a:ext cx="0" cy="0"/>
+          <a:chOff x="0" y="0"/>
+          <a:chExt cx="0" cy="0"/>
+        </a:xfrm>
+      </p:grpSpPr>
+      <p:pic>
+        <p:nvPicPr>
+          <p:cNvPr id="18" name="Picture 17">
+            <a:extLst>
+              <a:ext uri="{FF2B5EF4-FFF2-40B4-BE49-F238E27FC236}">
+                <a16:creationId xmlns:a16="http://schemas.microsoft.com/office/drawing/2014/main" id="{3D69B59F-D994-2285-6033-2FB458B34C42}"/>
+              </a:ext>
+            </a:extLst>
+          </p:cNvPr>
+          <p:cNvPicPr>
+            <a:picLocks noChangeAspect="1"/>
+          </p:cNvPicPr>
+          <p:nvPr/>
+        </p:nvPicPr>
+        <p:blipFill>
+          <a:blip r:embed="rId3">
+            <a:extLst>
+              <a:ext uri="{28A0092B-C50C-407E-A947-70E740481C1C}">
+                <a14:useLocalDpi xmlns:a14="http://schemas.microsoft.com/office/drawing/2010/main" val="0"/>
+              </a:ext>
+            </a:extLst>
+          </a:blip>
+          <a:stretch>
+            <a:fillRect/>
+          </a:stretch>
+        </p:blipFill>
+        <p:spPr>
+          <a:xfrm>
+            <a:off x="1746667" y="239641"/>
+            <a:ext cx="7702133" cy="6378718"/>
+          </a:xfrm>
+          <a:prstGeom prst="rect">
+            <a:avLst/>
+          </a:prstGeom>
+        </p:spPr>
+      </p:pic>
+      <p:sp>
+        <p:nvSpPr>
+          <p:cNvPr id="2" name="Title 3">
+            <a:extLst>
+              <a:ext uri="{FF2B5EF4-FFF2-40B4-BE49-F238E27FC236}">
+                <a16:creationId xmlns:a16="http://schemas.microsoft.com/office/drawing/2014/main" id="{92950DC0-0DE4-70B1-E1B2-7FB9773D61AE}"/>
+              </a:ext>
+            </a:extLst>
+          </p:cNvPr>
+          <p:cNvSpPr txBox="1">
+            <a:spLocks/>
+          </p:cNvSpPr>
+          <p:nvPr/>
+        </p:nvSpPr>
+        <p:spPr>
+          <a:xfrm>
+            <a:off x="5354407" y="114227"/>
+            <a:ext cx="7359704" cy="629121"/>
+          </a:xfrm>
+          <a:prstGeom prst="rect">
+            <a:avLst/>
+          </a:prstGeom>
+        </p:spPr>
+        <p:txBody>
+          <a:bodyPr/>
+          <a:lstStyle>
+            <a:lvl1pPr algn="l" defTabSz="914400" rtl="0" eaLnBrk="1" latinLnBrk="0" hangingPunct="1">
+              <a:lnSpc>
+                <a:spcPct val="90000"/>
+              </a:lnSpc>
+              <a:spcBef>
+                <a:spcPct val="0"/>
+              </a:spcBef>
+              <a:buNone/>
+              <a:defRPr sz="4400" kern="1200">
+                <a:solidFill>
+                  <a:schemeClr val="tx1"/>
+                </a:solidFill>
+                <a:latin typeface="+mj-lt"/>
+                <a:ea typeface="+mj-ea"/>
+                <a:cs typeface="+mj-cs"/>
+              </a:defRPr>
+            </a:lvl1pPr>
+          </a:lstStyle>
+          <a:p>
+            <a:r>
+              <a:rPr lang="en-US" dirty="0"/>
+              <a:t>Prev minus WT elegans and P</a:t>
+            </a:r>
+          </a:p>
+        </p:txBody>
+      </p:sp>
+    </p:spTree>
+    <p:extLst>
+      <p:ext uri="{BB962C8B-B14F-4D97-AF65-F5344CB8AC3E}">
+        <p14:creationId xmlns:p14="http://schemas.microsoft.com/office/powerpoint/2010/main" val="1887341186"/>
+      </p:ext>
+    </p:extLst>
+  </p:cSld>
+  <p:clrMapOvr>
+    <a:masterClrMapping/>
+  </p:clrMapOvr>
+</p:sld>
+</file>
+
+<file path=ppt/slides/slide15.xml><?xml version="1.0" encoding="utf-8"?>
+<p:sld xmlns:a="http://schemas.openxmlformats.org/drawingml/2006/main" xmlns:r="http://schemas.openxmlformats.org/officeDocument/2006/relationships" xmlns:p="http://schemas.openxmlformats.org/presentationml/2006/main">
+  <p:cSld>
+    <p:spTree>
+      <p:nvGrpSpPr>
+        <p:cNvPr id="1" name=""/>
+        <p:cNvGrpSpPr/>
+        <p:nvPr/>
+      </p:nvGrpSpPr>
+      <p:grpSpPr>
+        <a:xfrm>
+          <a:off x="0" y="0"/>
+          <a:ext cx="0" cy="0"/>
+          <a:chOff x="0" y="0"/>
+          <a:chExt cx="0" cy="0"/>
+        </a:xfrm>
+      </p:grpSpPr>
+      <p:sp>
+        <p:nvSpPr>
+          <p:cNvPr id="2" name="Title 1">
+            <a:extLst>
+              <a:ext uri="{FF2B5EF4-FFF2-40B4-BE49-F238E27FC236}">
+                <a16:creationId xmlns:a16="http://schemas.microsoft.com/office/drawing/2014/main" id="{D1566D96-5685-587C-BDD7-D2D849A6994D}"/>
+              </a:ext>
+            </a:extLst>
+          </p:cNvPr>
+          <p:cNvSpPr>
+            <a:spLocks noGrp="1"/>
+          </p:cNvSpPr>
+          <p:nvPr>
+            <p:ph type="title"/>
+          </p:nvPr>
+        </p:nvSpPr>
+        <p:spPr>
+          <a:xfrm>
+            <a:off x="149578" y="0"/>
+            <a:ext cx="10515600" cy="1325563"/>
+          </a:xfrm>
+        </p:spPr>
+        <p:txBody>
+          <a:bodyPr/>
+          <a:lstStyle/>
+          <a:p>
+            <a:r>
+              <a:rPr lang="en-US" dirty="0"/>
+              <a:t>All WT</a:t>
+            </a:r>
+          </a:p>
+        </p:txBody>
+      </p:sp>
+      <p:pic>
+        <p:nvPicPr>
+          <p:cNvPr id="4" name="Picture 3">
+            <a:extLst>
+              <a:ext uri="{FF2B5EF4-FFF2-40B4-BE49-F238E27FC236}">
+                <a16:creationId xmlns:a16="http://schemas.microsoft.com/office/drawing/2014/main" id="{76BB063A-F5E4-D460-81A5-D1FDDF041500}"/>
+              </a:ext>
+            </a:extLst>
+          </p:cNvPr>
+          <p:cNvPicPr>
+            <a:picLocks noChangeAspect="1"/>
+          </p:cNvPicPr>
+          <p:nvPr/>
+        </p:nvPicPr>
+        <p:blipFill>
+          <a:blip r:embed="rId2">
+            <a:extLst>
+              <a:ext uri="{28A0092B-C50C-407E-A947-70E740481C1C}">
+                <a14:useLocalDpi xmlns:a14="http://schemas.microsoft.com/office/drawing/2010/main" val="0"/>
+              </a:ext>
+            </a:extLst>
+          </a:blip>
+          <a:stretch>
+            <a:fillRect/>
+          </a:stretch>
+        </p:blipFill>
+        <p:spPr>
+          <a:xfrm>
+            <a:off x="2062475" y="292435"/>
+            <a:ext cx="9497347" cy="6517382"/>
+          </a:xfrm>
+          <a:prstGeom prst="rect">
+            <a:avLst/>
+          </a:prstGeom>
+        </p:spPr>
+      </p:pic>
+    </p:spTree>
+    <p:extLst>
+      <p:ext uri="{BB962C8B-B14F-4D97-AF65-F5344CB8AC3E}">
+        <p14:creationId xmlns:p14="http://schemas.microsoft.com/office/powerpoint/2010/main" val="653773994"/>
+      </p:ext>
+    </p:extLst>
+  </p:cSld>
+  <p:clrMapOvr>
+    <a:masterClrMapping/>
+  </p:clrMapOvr>
+</p:sld>
+</file>
+
+<file path=ppt/slides/slide16.xml><?xml version="1.0" encoding="utf-8"?>
+<p:sld xmlns:a="http://schemas.openxmlformats.org/drawingml/2006/main" xmlns:r="http://schemas.openxmlformats.org/officeDocument/2006/relationships" xmlns:p="http://schemas.openxmlformats.org/presentationml/2006/main">
+  <p:cSld>
+    <p:spTree>
+      <p:nvGrpSpPr>
+        <p:cNvPr id="1" name="">
+          <a:extLst>
+            <a:ext uri="{FF2B5EF4-FFF2-40B4-BE49-F238E27FC236}">
+              <a16:creationId xmlns:a16="http://schemas.microsoft.com/office/drawing/2014/main" id="{E0D1D141-BF55-6CFA-D0D4-E2DF47FE6C02}"/>
+            </a:ext>
+          </a:extLst>
+        </p:cNvPr>
+        <p:cNvGrpSpPr/>
+        <p:nvPr/>
+      </p:nvGrpSpPr>
+      <p:grpSpPr>
+        <a:xfrm>
+          <a:off x="0" y="0"/>
+          <a:ext cx="0" cy="0"/>
+          <a:chOff x="0" y="0"/>
+          <a:chExt cx="0" cy="0"/>
+        </a:xfrm>
+      </p:grpSpPr>
+      <p:sp>
+        <p:nvSpPr>
+          <p:cNvPr id="4" name="Title 3">
+            <a:extLst>
+              <a:ext uri="{FF2B5EF4-FFF2-40B4-BE49-F238E27FC236}">
+                <a16:creationId xmlns:a16="http://schemas.microsoft.com/office/drawing/2014/main" id="{F742240D-C979-78B2-8631-D9A15E3CC603}"/>
+              </a:ext>
+            </a:extLst>
+          </p:cNvPr>
+          <p:cNvSpPr>
+            <a:spLocks noGrp="1"/>
+          </p:cNvSpPr>
+          <p:nvPr>
+            <p:ph type="title"/>
+          </p:nvPr>
+        </p:nvSpPr>
+        <p:spPr>
+          <a:xfrm>
+            <a:off x="159774" y="70158"/>
+            <a:ext cx="10515600" cy="1325563"/>
+          </a:xfrm>
+        </p:spPr>
+        <p:txBody>
+          <a:bodyPr/>
+          <a:lstStyle/>
+          <a:p>
+            <a:r>
+              <a:rPr lang="en-US" dirty="0"/>
+              <a:t>LVNV, T, and WT sirtalis</a:t>
+            </a:r>
+          </a:p>
+        </p:txBody>
+      </p:sp>
+      <p:pic>
+        <p:nvPicPr>
+          <p:cNvPr id="16" name="Picture 15">
+            <a:extLst>
+              <a:ext uri="{FF2B5EF4-FFF2-40B4-BE49-F238E27FC236}">
+                <a16:creationId xmlns:a16="http://schemas.microsoft.com/office/drawing/2014/main" id="{0FAC8C6F-5236-4C3D-4ADB-86FFAE71D67C}"/>
+              </a:ext>
+            </a:extLst>
+          </p:cNvPr>
+          <p:cNvPicPr>
+            <a:picLocks noChangeAspect="1"/>
+          </p:cNvPicPr>
+          <p:nvPr/>
+        </p:nvPicPr>
+        <p:blipFill>
+          <a:blip r:embed="rId3">
+            <a:extLst>
+              <a:ext uri="{28A0092B-C50C-407E-A947-70E740481C1C}">
+                <a14:useLocalDpi xmlns:a14="http://schemas.microsoft.com/office/drawing/2010/main" val="0"/>
+              </a:ext>
+            </a:extLst>
+          </a:blip>
+          <a:stretch>
+            <a:fillRect/>
+          </a:stretch>
+        </p:blipFill>
+        <p:spPr>
+          <a:xfrm>
+            <a:off x="2796533" y="1155851"/>
+            <a:ext cx="6598933" cy="5465075"/>
+          </a:xfrm>
+          <a:prstGeom prst="rect">
+            <a:avLst/>
+          </a:prstGeom>
+        </p:spPr>
+      </p:pic>
+    </p:spTree>
+    <p:extLst>
+      <p:ext uri="{BB962C8B-B14F-4D97-AF65-F5344CB8AC3E}">
+        <p14:creationId xmlns:p14="http://schemas.microsoft.com/office/powerpoint/2010/main" val="701903127"/>
+      </p:ext>
+    </p:extLst>
+  </p:cSld>
+  <p:clrMapOvr>
+    <a:masterClrMapping/>
+  </p:clrMapOvr>
+</p:sld>
+</file>
+
+<file path=ppt/slides/slide17.xml><?xml version="1.0" encoding="utf-8"?>
+<p:sld xmlns:a="http://schemas.openxmlformats.org/drawingml/2006/main" xmlns:r="http://schemas.openxmlformats.org/officeDocument/2006/relationships" xmlns:p="http://schemas.openxmlformats.org/presentationml/2006/main">
+  <p:cSld>
+    <p:spTree>
+      <p:nvGrpSpPr>
+        <p:cNvPr id="1" name="">
+          <a:extLst>
+            <a:ext uri="{FF2B5EF4-FFF2-40B4-BE49-F238E27FC236}">
+              <a16:creationId xmlns:a16="http://schemas.microsoft.com/office/drawing/2014/main" id="{F49B1AFC-8B86-2BEB-43D5-CB26CC07E4D1}"/>
+            </a:ext>
+          </a:extLst>
+        </p:cNvPr>
+        <p:cNvGrpSpPr/>
+        <p:nvPr/>
+      </p:nvGrpSpPr>
+      <p:grpSpPr>
+        <a:xfrm>
+          <a:off x="0" y="0"/>
+          <a:ext cx="0" cy="0"/>
+          <a:chOff x="0" y="0"/>
+          <a:chExt cx="0" cy="0"/>
+        </a:xfrm>
+      </p:grpSpPr>
+      <p:sp>
+        <p:nvSpPr>
+          <p:cNvPr id="4" name="Title 3">
+            <a:extLst>
+              <a:ext uri="{FF2B5EF4-FFF2-40B4-BE49-F238E27FC236}">
+                <a16:creationId xmlns:a16="http://schemas.microsoft.com/office/drawing/2014/main" id="{427A2538-AA41-71FA-61B6-FE951563DB19}"/>
+              </a:ext>
+            </a:extLst>
+          </p:cNvPr>
+          <p:cNvSpPr>
+            <a:spLocks noGrp="1"/>
+          </p:cNvSpPr>
+          <p:nvPr>
+            <p:ph type="title"/>
+          </p:nvPr>
+        </p:nvSpPr>
+        <p:spPr>
+          <a:xfrm>
+            <a:off x="81116" y="0"/>
+            <a:ext cx="10515600" cy="1325563"/>
+          </a:xfrm>
+        </p:spPr>
+        <p:txBody>
+          <a:bodyPr/>
+          <a:lstStyle/>
+          <a:p>
+            <a:r>
+              <a:rPr lang="en-US" dirty="0"/>
+              <a:t>LVNV, EPN, T, and WT sirtalis</a:t>
+            </a:r>
+          </a:p>
+        </p:txBody>
+      </p:sp>
+      <p:pic>
+        <p:nvPicPr>
+          <p:cNvPr id="6" name="Picture 5">
+            <a:extLst>
+              <a:ext uri="{FF2B5EF4-FFF2-40B4-BE49-F238E27FC236}">
+                <a16:creationId xmlns:a16="http://schemas.microsoft.com/office/drawing/2014/main" id="{EC278E12-1BA9-99C0-B3E6-FDB4D1AF1D09}"/>
+              </a:ext>
+            </a:extLst>
+          </p:cNvPr>
+          <p:cNvPicPr>
+            <a:picLocks noChangeAspect="1"/>
+          </p:cNvPicPr>
+          <p:nvPr/>
+        </p:nvPicPr>
+        <p:blipFill>
+          <a:blip r:embed="rId3">
+            <a:extLst>
+              <a:ext uri="{28A0092B-C50C-407E-A947-70E740481C1C}">
+                <a14:useLocalDpi xmlns:a14="http://schemas.microsoft.com/office/drawing/2010/main" val="0"/>
+              </a:ext>
+            </a:extLst>
+          </a:blip>
+          <a:stretch>
+            <a:fillRect/>
+          </a:stretch>
+        </p:blipFill>
+        <p:spPr>
+          <a:xfrm>
+            <a:off x="2602718" y="1001263"/>
+            <a:ext cx="6986564" cy="5786102"/>
+          </a:xfrm>
+          <a:prstGeom prst="rect">
+            <a:avLst/>
+          </a:prstGeom>
+        </p:spPr>
+      </p:pic>
+    </p:spTree>
+    <p:extLst>
+      <p:ext uri="{BB962C8B-B14F-4D97-AF65-F5344CB8AC3E}">
+        <p14:creationId xmlns:p14="http://schemas.microsoft.com/office/powerpoint/2010/main" val="2024328479"/>
+      </p:ext>
+    </p:extLst>
+  </p:cSld>
+  <p:clrMapOvr>
+    <a:masterClrMapping/>
+  </p:clrMapOvr>
+</p:sld>
+</file>
+
+<file path=ppt/slides/slide18.xml><?xml version="1.0" encoding="utf-8"?>
+<p:sld xmlns:a="http://schemas.openxmlformats.org/drawingml/2006/main" xmlns:r="http://schemas.openxmlformats.org/officeDocument/2006/relationships" xmlns:p="http://schemas.openxmlformats.org/presentationml/2006/main">
+  <p:cSld>
+    <p:spTree>
+      <p:nvGrpSpPr>
+        <p:cNvPr id="1" name="">
+          <a:extLst>
+            <a:ext uri="{FF2B5EF4-FFF2-40B4-BE49-F238E27FC236}">
+              <a16:creationId xmlns:a16="http://schemas.microsoft.com/office/drawing/2014/main" id="{BA3FE163-3652-8D85-7226-16BF78E94D3B}"/>
+            </a:ext>
+          </a:extLst>
+        </p:cNvPr>
+        <p:cNvGrpSpPr/>
+        <p:nvPr/>
+      </p:nvGrpSpPr>
+      <p:grpSpPr>
+        <a:xfrm>
+          <a:off x="0" y="0"/>
+          <a:ext cx="0" cy="0"/>
+          <a:chOff x="0" y="0"/>
+          <a:chExt cx="0" cy="0"/>
+        </a:xfrm>
+      </p:grpSpPr>
+      <p:sp>
+        <p:nvSpPr>
+          <p:cNvPr id="4" name="Title 3">
+            <a:extLst>
+              <a:ext uri="{FF2B5EF4-FFF2-40B4-BE49-F238E27FC236}">
+                <a16:creationId xmlns:a16="http://schemas.microsoft.com/office/drawing/2014/main" id="{933E5EC4-F47F-D7DB-6D35-53F8B9280C63}"/>
+              </a:ext>
+            </a:extLst>
+          </p:cNvPr>
+          <p:cNvSpPr>
+            <a:spLocks noGrp="1"/>
+          </p:cNvSpPr>
+          <p:nvPr>
+            <p:ph type="title"/>
+          </p:nvPr>
+        </p:nvSpPr>
+        <p:spPr>
+          <a:xfrm>
+            <a:off x="90948" y="67362"/>
+            <a:ext cx="10515600" cy="1325563"/>
+          </a:xfrm>
+        </p:spPr>
+        <p:txBody>
+          <a:bodyPr/>
+          <a:lstStyle/>
+          <a:p>
+            <a:r>
+              <a:rPr lang="en-US" dirty="0"/>
+              <a:t>LVNV, WT sirtalis, T, and WT </a:t>
+            </a:r>
+            <a:r>
+              <a:rPr lang="en-US" dirty="0" err="1"/>
+              <a:t>hammondii</a:t>
+            </a:r>
+            <a:endParaRPr lang="en-US" dirty="0"/>
+          </a:p>
+        </p:txBody>
+      </p:sp>
+      <p:pic>
+        <p:nvPicPr>
+          <p:cNvPr id="14" name="Picture 13">
+            <a:extLst>
+              <a:ext uri="{FF2B5EF4-FFF2-40B4-BE49-F238E27FC236}">
+                <a16:creationId xmlns:a16="http://schemas.microsoft.com/office/drawing/2014/main" id="{B7A2896C-40EB-5300-6D87-E0679A1C4924}"/>
+              </a:ext>
+            </a:extLst>
+          </p:cNvPr>
+          <p:cNvPicPr>
+            <a:picLocks noChangeAspect="1"/>
+          </p:cNvPicPr>
+          <p:nvPr/>
+        </p:nvPicPr>
+        <p:blipFill>
+          <a:blip r:embed="rId3">
+            <a:extLst>
+              <a:ext uri="{28A0092B-C50C-407E-A947-70E740481C1C}">
+                <a14:useLocalDpi xmlns:a14="http://schemas.microsoft.com/office/drawing/2010/main" val="0"/>
+              </a:ext>
+            </a:extLst>
+          </a:blip>
+          <a:stretch>
+            <a:fillRect/>
+          </a:stretch>
+        </p:blipFill>
+        <p:spPr>
+          <a:xfrm>
+            <a:off x="2796533" y="1325563"/>
+            <a:ext cx="6598933" cy="5465075"/>
+          </a:xfrm>
+          <a:prstGeom prst="rect">
+            <a:avLst/>
+          </a:prstGeom>
+        </p:spPr>
+      </p:pic>
+    </p:spTree>
+    <p:extLst>
+      <p:ext uri="{BB962C8B-B14F-4D97-AF65-F5344CB8AC3E}">
+        <p14:creationId xmlns:p14="http://schemas.microsoft.com/office/powerpoint/2010/main" val="2130636375"/>
+      </p:ext>
+    </p:extLst>
+  </p:cSld>
+  <p:clrMapOvr>
+    <a:masterClrMapping/>
+  </p:clrMapOvr>
+</p:sld>
+</file>
+
+<file path=ppt/slides/slide19.xml><?xml version="1.0" encoding="utf-8"?>
+<p:sld xmlns:a="http://schemas.openxmlformats.org/drawingml/2006/main" xmlns:r="http://schemas.openxmlformats.org/officeDocument/2006/relationships" xmlns:p="http://schemas.openxmlformats.org/presentationml/2006/main">
+  <p:cSld>
+    <p:spTree>
+      <p:nvGrpSpPr>
+        <p:cNvPr id="1" name="">
+          <a:extLst>
+            <a:ext uri="{FF2B5EF4-FFF2-40B4-BE49-F238E27FC236}">
+              <a16:creationId xmlns:a16="http://schemas.microsoft.com/office/drawing/2014/main" id="{F001F2E3-B7FE-BC9A-D078-26F4DE252C7F}"/>
+            </a:ext>
+          </a:extLst>
+        </p:cNvPr>
+        <p:cNvGrpSpPr/>
+        <p:nvPr/>
+      </p:nvGrpSpPr>
+      <p:grpSpPr>
+        <a:xfrm>
+          <a:off x="0" y="0"/>
+          <a:ext cx="0" cy="0"/>
+          <a:chOff x="0" y="0"/>
+          <a:chExt cx="0" cy="0"/>
+        </a:xfrm>
+      </p:grpSpPr>
+      <p:pic>
+        <p:nvPicPr>
+          <p:cNvPr id="8" name="Picture 7">
+            <a:extLst>
+              <a:ext uri="{FF2B5EF4-FFF2-40B4-BE49-F238E27FC236}">
+                <a16:creationId xmlns:a16="http://schemas.microsoft.com/office/drawing/2014/main" id="{38A6683D-0A4C-6246-BAEE-57F47B38BC00}"/>
+              </a:ext>
+            </a:extLst>
+          </p:cNvPr>
+          <p:cNvPicPr>
+            <a:picLocks noChangeAspect="1"/>
+          </p:cNvPicPr>
+          <p:nvPr/>
+        </p:nvPicPr>
+        <p:blipFill>
+          <a:blip r:embed="rId3">
+            <a:extLst>
+              <a:ext uri="{28A0092B-C50C-407E-A947-70E740481C1C}">
+                <a14:useLocalDpi xmlns:a14="http://schemas.microsoft.com/office/drawing/2010/main" val="0"/>
+              </a:ext>
+            </a:extLst>
+          </a:blip>
+          <a:stretch>
+            <a:fillRect/>
+          </a:stretch>
+        </p:blipFill>
+        <p:spPr>
+          <a:xfrm>
+            <a:off x="2425422" y="1016982"/>
+            <a:ext cx="7052874" cy="5841018"/>
+          </a:xfrm>
+          <a:prstGeom prst="rect">
+            <a:avLst/>
+          </a:prstGeom>
+        </p:spPr>
+      </p:pic>
+      <p:sp>
+        <p:nvSpPr>
+          <p:cNvPr id="2" name="Title 3">
+            <a:extLst>
+              <a:ext uri="{FF2B5EF4-FFF2-40B4-BE49-F238E27FC236}">
+                <a16:creationId xmlns:a16="http://schemas.microsoft.com/office/drawing/2014/main" id="{0F526DD4-1F02-90A2-21E1-F5ED9FF065F5}"/>
+              </a:ext>
+            </a:extLst>
+          </p:cNvPr>
+          <p:cNvSpPr txBox="1">
+            <a:spLocks/>
+          </p:cNvSpPr>
+          <p:nvPr/>
+        </p:nvSpPr>
+        <p:spPr>
+          <a:xfrm>
+            <a:off x="90948" y="67362"/>
+            <a:ext cx="10515600" cy="1325563"/>
+          </a:xfrm>
+          <a:prstGeom prst="rect">
+            <a:avLst/>
+          </a:prstGeom>
+        </p:spPr>
+        <p:txBody>
+          <a:bodyPr vert="horz" lIns="91440" tIns="45720" rIns="91440" bIns="45720" rtlCol="0" anchor="ctr">
+            <a:normAutofit/>
+          </a:bodyPr>
+          <a:lstStyle>
+            <a:lvl1pPr algn="l" defTabSz="914400" rtl="0" eaLnBrk="1" latinLnBrk="0" hangingPunct="1">
+              <a:lnSpc>
+                <a:spcPct val="90000"/>
+              </a:lnSpc>
+              <a:spcBef>
+                <a:spcPct val="0"/>
+              </a:spcBef>
+              <a:buNone/>
+              <a:defRPr sz="4400" kern="1200">
+                <a:solidFill>
+                  <a:schemeClr val="tx1"/>
+                </a:solidFill>
+                <a:latin typeface="+mj-lt"/>
+                <a:ea typeface="+mj-ea"/>
+                <a:cs typeface="+mj-cs"/>
+              </a:defRPr>
+            </a:lvl1pPr>
+          </a:lstStyle>
+          <a:p>
+            <a:r>
+              <a:rPr lang="en-US"/>
+              <a:t>LVNV, WT sirtalis, T, and WT hammondii</a:t>
+            </a:r>
+            <a:endParaRPr lang="en-US" dirty="0"/>
+          </a:p>
+        </p:txBody>
+      </p:sp>
+    </p:spTree>
+    <p:extLst>
+      <p:ext uri="{BB962C8B-B14F-4D97-AF65-F5344CB8AC3E}">
+        <p14:creationId xmlns:p14="http://schemas.microsoft.com/office/powerpoint/2010/main" val="2730062183"/>
+      </p:ext>
+    </p:extLst>
+  </p:cSld>
+  <p:clrMapOvr>
+    <a:masterClrMapping/>
+  </p:clrMapOvr>
+</p:sld>
+</file>
+
+<file path=ppt/slides/slide2.xml><?xml version="1.0" encoding="utf-8"?>
+<p:sld xmlns:a="http://schemas.openxmlformats.org/drawingml/2006/main" xmlns:r="http://schemas.openxmlformats.org/officeDocument/2006/relationships" xmlns:p="http://schemas.openxmlformats.org/presentationml/2006/main">
+  <p:cSld>
+    <p:spTree>
+      <p:nvGrpSpPr>
+        <p:cNvPr id="1" name=""/>
+        <p:cNvGrpSpPr/>
+        <p:nvPr/>
+      </p:nvGrpSpPr>
+      <p:grpSpPr>
+        <a:xfrm>
+          <a:off x="0" y="0"/>
+          <a:ext cx="0" cy="0"/>
+          <a:chOff x="0" y="0"/>
+          <a:chExt cx="0" cy="0"/>
+        </a:xfrm>
+      </p:grpSpPr>
+      <p:sp>
+        <p:nvSpPr>
+          <p:cNvPr id="4" name="Title 3">
+            <a:extLst>
+              <a:ext uri="{FF2B5EF4-FFF2-40B4-BE49-F238E27FC236}">
+                <a16:creationId xmlns:a16="http://schemas.microsoft.com/office/drawing/2014/main" id="{3BB4873F-15A7-243F-3F5E-1339E0076EF6}"/>
+              </a:ext>
+            </a:extLst>
+          </p:cNvPr>
+          <p:cNvSpPr>
+            <a:spLocks noGrp="1"/>
+          </p:cNvSpPr>
+          <p:nvPr>
+            <p:ph type="title"/>
+          </p:nvPr>
+        </p:nvSpPr>
+        <p:spPr/>
+        <p:txBody>
+          <a:bodyPr/>
+          <a:lstStyle/>
+          <a:p>
+            <a:r>
+              <a:rPr lang="en-US" dirty="0"/>
+              <a:t>Transient contractions (C4P)</a:t>
+            </a:r>
+          </a:p>
+        </p:txBody>
+      </p:sp>
+      <p:sp>
+        <p:nvSpPr>
+          <p:cNvPr id="5" name="Text Placeholder 4">
+            <a:extLst>
+              <a:ext uri="{FF2B5EF4-FFF2-40B4-BE49-F238E27FC236}">
+                <a16:creationId xmlns:a16="http://schemas.microsoft.com/office/drawing/2014/main" id="{3879C9DE-A46A-AA88-41BA-2B9B8190A14C}"/>
+              </a:ext>
+            </a:extLst>
+          </p:cNvPr>
+          <p:cNvSpPr>
+            <a:spLocks noGrp="1"/>
+          </p:cNvSpPr>
+          <p:nvPr>
+            <p:ph type="body" idx="1"/>
+          </p:nvPr>
+        </p:nvSpPr>
+        <p:spPr/>
+        <p:txBody>
+          <a:bodyPr/>
+          <a:lstStyle/>
+          <a:p>
+            <a:r>
+              <a:rPr lang="en-US" dirty="0"/>
+              <a:t>I apologize that the genotype colors are inconsistent across plots, I realized this as I was putting it together and I don’t have time to fix it tonight but I will get it fixed by whenever we next meet</a:t>
+            </a:r>
+          </a:p>
+        </p:txBody>
+      </p:sp>
+    </p:spTree>
+    <p:extLst>
+      <p:ext uri="{BB962C8B-B14F-4D97-AF65-F5344CB8AC3E}">
+        <p14:creationId xmlns:p14="http://schemas.microsoft.com/office/powerpoint/2010/main" val="2886554321"/>
+      </p:ext>
+    </p:extLst>
+  </p:cSld>
+  <p:clrMapOvr>
+    <a:masterClrMapping/>
+  </p:clrMapOvr>
+</p:sld>
+</file>
+
+<file path=ppt/slides/slide20.xml><?xml version="1.0" encoding="utf-8"?>
+<p:sld xmlns:a="http://schemas.openxmlformats.org/drawingml/2006/main" xmlns:r="http://schemas.openxmlformats.org/officeDocument/2006/relationships" xmlns:p="http://schemas.openxmlformats.org/presentationml/2006/main">
+  <p:cSld>
+    <p:spTree>
+      <p:nvGrpSpPr>
+        <p:cNvPr id="1" name="">
+          <a:extLst>
+            <a:ext uri="{FF2B5EF4-FFF2-40B4-BE49-F238E27FC236}">
+              <a16:creationId xmlns:a16="http://schemas.microsoft.com/office/drawing/2014/main" id="{4460BEC3-72FD-0E53-909F-5F535746AA26}"/>
+            </a:ext>
+          </a:extLst>
+        </p:cNvPr>
+        <p:cNvGrpSpPr/>
+        <p:nvPr/>
+      </p:nvGrpSpPr>
+      <p:grpSpPr>
+        <a:xfrm>
+          <a:off x="0" y="0"/>
+          <a:ext cx="0" cy="0"/>
+          <a:chOff x="0" y="0"/>
+          <a:chExt cx="0" cy="0"/>
+        </a:xfrm>
+      </p:grpSpPr>
+      <p:pic>
+        <p:nvPicPr>
+          <p:cNvPr id="10" name="Picture 9">
+            <a:extLst>
+              <a:ext uri="{FF2B5EF4-FFF2-40B4-BE49-F238E27FC236}">
+                <a16:creationId xmlns:a16="http://schemas.microsoft.com/office/drawing/2014/main" id="{B8DFD697-9042-586E-5236-022A5816D0AB}"/>
+              </a:ext>
+            </a:extLst>
+          </p:cNvPr>
+          <p:cNvPicPr>
+            <a:picLocks noChangeAspect="1"/>
+          </p:cNvPicPr>
+          <p:nvPr/>
+        </p:nvPicPr>
+        <p:blipFill>
+          <a:blip r:embed="rId3">
+            <a:extLst>
+              <a:ext uri="{28A0092B-C50C-407E-A947-70E740481C1C}">
+                <a14:useLocalDpi xmlns:a14="http://schemas.microsoft.com/office/drawing/2010/main" val="0"/>
+              </a:ext>
+            </a:extLst>
+          </a:blip>
+          <a:stretch>
+            <a:fillRect/>
+          </a:stretch>
+        </p:blipFill>
+        <p:spPr>
+          <a:xfrm>
+            <a:off x="2870391" y="1124280"/>
+            <a:ext cx="6598933" cy="5465075"/>
+          </a:xfrm>
+          <a:prstGeom prst="rect">
+            <a:avLst/>
+          </a:prstGeom>
+        </p:spPr>
+      </p:pic>
+      <p:sp>
+        <p:nvSpPr>
+          <p:cNvPr id="2" name="Title 3">
+            <a:extLst>
+              <a:ext uri="{FF2B5EF4-FFF2-40B4-BE49-F238E27FC236}">
+                <a16:creationId xmlns:a16="http://schemas.microsoft.com/office/drawing/2014/main" id="{F513DE2B-F1AD-A55F-C524-CAAE9815B878}"/>
+              </a:ext>
+            </a:extLst>
+          </p:cNvPr>
+          <p:cNvSpPr txBox="1">
+            <a:spLocks/>
+          </p:cNvSpPr>
+          <p:nvPr/>
+        </p:nvSpPr>
+        <p:spPr>
+          <a:xfrm>
+            <a:off x="90948" y="67362"/>
+            <a:ext cx="10515600" cy="1325563"/>
+          </a:xfrm>
+          <a:prstGeom prst="rect">
+            <a:avLst/>
+          </a:prstGeom>
+        </p:spPr>
+        <p:txBody>
+          <a:bodyPr vert="horz" lIns="91440" tIns="45720" rIns="91440" bIns="45720" rtlCol="0" anchor="ctr">
+            <a:normAutofit/>
+          </a:bodyPr>
+          <a:lstStyle>
+            <a:lvl1pPr algn="l" defTabSz="914400" rtl="0" eaLnBrk="1" latinLnBrk="0" hangingPunct="1">
+              <a:lnSpc>
+                <a:spcPct val="90000"/>
+              </a:lnSpc>
+              <a:spcBef>
+                <a:spcPct val="0"/>
+              </a:spcBef>
+              <a:buNone/>
+              <a:defRPr sz="4400" kern="1200">
+                <a:solidFill>
+                  <a:schemeClr val="tx1"/>
+                </a:solidFill>
+                <a:latin typeface="+mj-lt"/>
+                <a:ea typeface="+mj-ea"/>
+                <a:cs typeface="+mj-cs"/>
+              </a:defRPr>
+            </a:lvl1pPr>
+          </a:lstStyle>
+          <a:p>
+            <a:r>
+              <a:rPr lang="en-US"/>
+              <a:t>LVNV, WT sirtalis, T, and WT hammondii</a:t>
+            </a:r>
+            <a:endParaRPr lang="en-US" dirty="0"/>
+          </a:p>
+        </p:txBody>
+      </p:sp>
+    </p:spTree>
+    <p:extLst>
+      <p:ext uri="{BB962C8B-B14F-4D97-AF65-F5344CB8AC3E}">
+        <p14:creationId xmlns:p14="http://schemas.microsoft.com/office/powerpoint/2010/main" val="4275669859"/>
+      </p:ext>
+    </p:extLst>
+  </p:cSld>
+  <p:clrMapOvr>
+    <a:masterClrMapping/>
+  </p:clrMapOvr>
+</p:sld>
+</file>
+
+<file path=ppt/slides/slide21.xml><?xml version="1.0" encoding="utf-8"?>
+<p:sld xmlns:a="http://schemas.openxmlformats.org/drawingml/2006/main" xmlns:r="http://schemas.openxmlformats.org/officeDocument/2006/relationships" xmlns:p="http://schemas.openxmlformats.org/presentationml/2006/main">
+  <p:cSld>
+    <p:spTree>
+      <p:nvGrpSpPr>
+        <p:cNvPr id="1" name="">
+          <a:extLst>
+            <a:ext uri="{FF2B5EF4-FFF2-40B4-BE49-F238E27FC236}">
+              <a16:creationId xmlns:a16="http://schemas.microsoft.com/office/drawing/2014/main" id="{C1043B44-34D3-19EA-DD84-E70773487328}"/>
+            </a:ext>
+          </a:extLst>
+        </p:cNvPr>
+        <p:cNvGrpSpPr/>
+        <p:nvPr/>
+      </p:nvGrpSpPr>
+      <p:grpSpPr>
+        <a:xfrm>
+          <a:off x="0" y="0"/>
+          <a:ext cx="0" cy="0"/>
+          <a:chOff x="0" y="0"/>
+          <a:chExt cx="0" cy="0"/>
+        </a:xfrm>
+      </p:grpSpPr>
+      <p:pic>
+        <p:nvPicPr>
+          <p:cNvPr id="12" name="Picture 11">
+            <a:extLst>
+              <a:ext uri="{FF2B5EF4-FFF2-40B4-BE49-F238E27FC236}">
+                <a16:creationId xmlns:a16="http://schemas.microsoft.com/office/drawing/2014/main" id="{584685CD-EDF6-07EE-727F-E35EC68EA9F1}"/>
+              </a:ext>
+            </a:extLst>
+          </p:cNvPr>
+          <p:cNvPicPr>
+            <a:picLocks noChangeAspect="1"/>
+          </p:cNvPicPr>
+          <p:nvPr/>
+        </p:nvPicPr>
+        <p:blipFill>
+          <a:blip r:embed="rId3">
+            <a:extLst>
+              <a:ext uri="{28A0092B-C50C-407E-A947-70E740481C1C}">
+                <a14:useLocalDpi xmlns:a14="http://schemas.microsoft.com/office/drawing/2010/main" val="0"/>
+              </a:ext>
+            </a:extLst>
+          </a:blip>
+          <a:stretch>
+            <a:fillRect/>
+          </a:stretch>
+        </p:blipFill>
+        <p:spPr>
+          <a:xfrm>
+            <a:off x="2912236" y="1116036"/>
+            <a:ext cx="6598933" cy="5465075"/>
+          </a:xfrm>
+          <a:prstGeom prst="rect">
+            <a:avLst/>
+          </a:prstGeom>
+        </p:spPr>
+      </p:pic>
+      <p:sp>
+        <p:nvSpPr>
+          <p:cNvPr id="2" name="Title 3">
+            <a:extLst>
+              <a:ext uri="{FF2B5EF4-FFF2-40B4-BE49-F238E27FC236}">
+                <a16:creationId xmlns:a16="http://schemas.microsoft.com/office/drawing/2014/main" id="{A5044021-225C-787E-D993-31352B208DBF}"/>
+              </a:ext>
+            </a:extLst>
+          </p:cNvPr>
+          <p:cNvSpPr txBox="1">
+            <a:spLocks/>
+          </p:cNvSpPr>
+          <p:nvPr/>
+        </p:nvSpPr>
+        <p:spPr>
+          <a:xfrm>
+            <a:off x="90948" y="67362"/>
+            <a:ext cx="10515600" cy="1325563"/>
+          </a:xfrm>
+          <a:prstGeom prst="rect">
+            <a:avLst/>
+          </a:prstGeom>
+        </p:spPr>
+        <p:txBody>
+          <a:bodyPr vert="horz" lIns="91440" tIns="45720" rIns="91440" bIns="45720" rtlCol="0" anchor="ctr">
+            <a:normAutofit/>
+          </a:bodyPr>
+          <a:lstStyle>
+            <a:lvl1pPr algn="l" defTabSz="914400" rtl="0" eaLnBrk="1" latinLnBrk="0" hangingPunct="1">
+              <a:lnSpc>
+                <a:spcPct val="90000"/>
+              </a:lnSpc>
+              <a:spcBef>
+                <a:spcPct val="0"/>
+              </a:spcBef>
+              <a:buNone/>
+              <a:defRPr sz="4400" kern="1200">
+                <a:solidFill>
+                  <a:schemeClr val="tx1"/>
+                </a:solidFill>
+                <a:latin typeface="+mj-lt"/>
+                <a:ea typeface="+mj-ea"/>
+                <a:cs typeface="+mj-cs"/>
+              </a:defRPr>
+            </a:lvl1pPr>
+          </a:lstStyle>
+          <a:p>
+            <a:r>
+              <a:rPr lang="en-US"/>
+              <a:t>LVNV, WT sirtalis, T, and WT hammondii</a:t>
+            </a:r>
+            <a:endParaRPr lang="en-US" dirty="0"/>
+          </a:p>
+        </p:txBody>
+      </p:sp>
+    </p:spTree>
+    <p:extLst>
+      <p:ext uri="{BB962C8B-B14F-4D97-AF65-F5344CB8AC3E}">
+        <p14:creationId xmlns:p14="http://schemas.microsoft.com/office/powerpoint/2010/main" val="1172107471"/>
+      </p:ext>
+    </p:extLst>
+  </p:cSld>
+  <p:clrMapOvr>
+    <a:masterClrMapping/>
+  </p:clrMapOvr>
+</p:sld>
+</file>
+
+<file path=ppt/slides/slide22.xml><?xml version="1.0" encoding="utf-8"?>
+<p:sld xmlns:a="http://schemas.openxmlformats.org/drawingml/2006/main" xmlns:r="http://schemas.openxmlformats.org/officeDocument/2006/relationships" xmlns:p="http://schemas.openxmlformats.org/presentationml/2006/main">
+  <p:cSld>
+    <p:spTree>
+      <p:nvGrpSpPr>
+        <p:cNvPr id="1" name=""/>
+        <p:cNvGrpSpPr/>
+        <p:nvPr/>
+      </p:nvGrpSpPr>
+      <p:grpSpPr>
+        <a:xfrm>
+          <a:off x="0" y="0"/>
+          <a:ext cx="0" cy="0"/>
+          <a:chOff x="0" y="0"/>
+          <a:chExt cx="0" cy="0"/>
+        </a:xfrm>
+      </p:grpSpPr>
+      <p:sp>
+        <p:nvSpPr>
+          <p:cNvPr id="3" name="Title 2">
+            <a:extLst>
+              <a:ext uri="{FF2B5EF4-FFF2-40B4-BE49-F238E27FC236}">
+                <a16:creationId xmlns:a16="http://schemas.microsoft.com/office/drawing/2014/main" id="{2E352018-A25E-B43D-5D53-3A06345616FE}"/>
+              </a:ext>
+            </a:extLst>
+          </p:cNvPr>
+          <p:cNvSpPr>
+            <a:spLocks noGrp="1"/>
+          </p:cNvSpPr>
+          <p:nvPr>
+            <p:ph type="title"/>
+          </p:nvPr>
+        </p:nvSpPr>
+        <p:spPr/>
+        <p:txBody>
+          <a:bodyPr/>
+          <a:lstStyle/>
+          <a:p>
+            <a:r>
+              <a:rPr lang="en-US" dirty="0"/>
+              <a:t>Rheobase protocol</a:t>
+            </a:r>
+          </a:p>
+        </p:txBody>
+      </p:sp>
+      <p:sp>
+        <p:nvSpPr>
+          <p:cNvPr id="4" name="Text Placeholder 3">
+            <a:extLst>
+              <a:ext uri="{FF2B5EF4-FFF2-40B4-BE49-F238E27FC236}">
+                <a16:creationId xmlns:a16="http://schemas.microsoft.com/office/drawing/2014/main" id="{B9F7088C-394E-DDDE-A7B3-3A0D1F4BD1B2}"/>
+              </a:ext>
+            </a:extLst>
+          </p:cNvPr>
+          <p:cNvSpPr>
+            <a:spLocks noGrp="1"/>
+          </p:cNvSpPr>
+          <p:nvPr>
+            <p:ph type="body" idx="1"/>
+          </p:nvPr>
+        </p:nvSpPr>
+        <p:spPr/>
+        <p:txBody>
+          <a:bodyPr>
+            <a:normAutofit fontScale="92500"/>
+          </a:bodyPr>
+          <a:lstStyle/>
+          <a:p>
+            <a:r>
+              <a:rPr lang="en-US" dirty="0"/>
+              <a:t>I did not get here because I was over-ambitious and also had to redo all the previous plots multiple times because of a series of silly errors but I will also have this before our next meeting (hopefully by the end of the week if you’re curious and want to see them sooner, we can probably meet via zoom while I’m gone if you want)</a:t>
+            </a:r>
+          </a:p>
+        </p:txBody>
+      </p:sp>
+    </p:spTree>
+    <p:extLst>
+      <p:ext uri="{BB962C8B-B14F-4D97-AF65-F5344CB8AC3E}">
+        <p14:creationId xmlns:p14="http://schemas.microsoft.com/office/powerpoint/2010/main" val="2411144924"/>
+      </p:ext>
+    </p:extLst>
+  </p:cSld>
+  <p:clrMapOvr>
+    <a:masterClrMapping/>
+  </p:clrMapOvr>
+</p:sld>
+</file>
+
+<file path=ppt/slides/slide3.xml><?xml version="1.0" encoding="utf-8"?>
+<p:sld xmlns:a="http://schemas.openxmlformats.org/drawingml/2006/main" xmlns:r="http://schemas.openxmlformats.org/officeDocument/2006/relationships" xmlns:p="http://schemas.openxmlformats.org/presentationml/2006/main">
+  <p:cSld>
+    <p:spTree>
+      <p:nvGrpSpPr>
+        <p:cNvPr id="1" name=""/>
+        <p:cNvGrpSpPr/>
+        <p:nvPr/>
+      </p:nvGrpSpPr>
+      <p:grpSpPr>
+        <a:xfrm>
+          <a:off x="0" y="0"/>
+          <a:ext cx="0" cy="0"/>
+          <a:chOff x="0" y="0"/>
+          <a:chExt cx="0" cy="0"/>
+        </a:xfrm>
+      </p:grpSpPr>
+      <p:sp>
+        <p:nvSpPr>
+          <p:cNvPr id="4" name="Title 3">
+            <a:extLst>
+              <a:ext uri="{FF2B5EF4-FFF2-40B4-BE49-F238E27FC236}">
+                <a16:creationId xmlns:a16="http://schemas.microsoft.com/office/drawing/2014/main" id="{3AC523F2-51FA-EFF8-87FC-2F8CF76C4544}"/>
+              </a:ext>
+            </a:extLst>
+          </p:cNvPr>
+          <p:cNvSpPr>
+            <a:spLocks noGrp="1"/>
+          </p:cNvSpPr>
+          <p:nvPr>
+            <p:ph type="title"/>
+          </p:nvPr>
+        </p:nvSpPr>
+        <p:spPr/>
+        <p:txBody>
+          <a:bodyPr/>
+          <a:lstStyle/>
+          <a:p>
+            <a:r>
+              <a:rPr lang="en-US" dirty="0"/>
+              <a:t>All</a:t>
+            </a:r>
+          </a:p>
+        </p:txBody>
+      </p:sp>
+      <p:pic>
+        <p:nvPicPr>
+          <p:cNvPr id="6" name="Picture 5">
+            <a:extLst>
+              <a:ext uri="{FF2B5EF4-FFF2-40B4-BE49-F238E27FC236}">
+                <a16:creationId xmlns:a16="http://schemas.microsoft.com/office/drawing/2014/main" id="{BBE36E2F-E4EC-2785-3414-84BD1037F32E}"/>
+              </a:ext>
+            </a:extLst>
+          </p:cNvPr>
+          <p:cNvPicPr>
+            <a:picLocks noChangeAspect="1"/>
+          </p:cNvPicPr>
+          <p:nvPr/>
+        </p:nvPicPr>
+        <p:blipFill>
+          <a:blip r:embed="rId2">
+            <a:extLst>
+              <a:ext uri="{28A0092B-C50C-407E-A947-70E740481C1C}">
+                <a14:useLocalDpi xmlns:a14="http://schemas.microsoft.com/office/drawing/2010/main" val="0"/>
+              </a:ext>
+            </a:extLst>
+          </a:blip>
+          <a:stretch>
+            <a:fillRect/>
+          </a:stretch>
+        </p:blipFill>
+        <p:spPr>
+          <a:xfrm>
+            <a:off x="1738489" y="365125"/>
+            <a:ext cx="9200444" cy="6313638"/>
+          </a:xfrm>
+          <a:prstGeom prst="rect">
+            <a:avLst/>
+          </a:prstGeom>
+        </p:spPr>
+      </p:pic>
+    </p:spTree>
+    <p:extLst>
+      <p:ext uri="{BB962C8B-B14F-4D97-AF65-F5344CB8AC3E}">
+        <p14:creationId xmlns:p14="http://schemas.microsoft.com/office/powerpoint/2010/main" val="1316905677"/>
+      </p:ext>
+    </p:extLst>
+  </p:cSld>
+  <p:clrMapOvr>
+    <a:masterClrMapping/>
+  </p:clrMapOvr>
+</p:sld>
+</file>
+
+<file path=ppt/slides/slide4.xml><?xml version="1.0" encoding="utf-8"?>
+<p:sld xmlns:a="http://schemas.openxmlformats.org/drawingml/2006/main" xmlns:r="http://schemas.openxmlformats.org/officeDocument/2006/relationships" xmlns:p="http://schemas.openxmlformats.org/presentationml/2006/main">
+  <p:cSld>
+    <p:spTree>
+      <p:nvGrpSpPr>
+        <p:cNvPr id="1" name=""/>
+        <p:cNvGrpSpPr/>
+        <p:nvPr/>
+      </p:nvGrpSpPr>
+      <p:grpSpPr>
+        <a:xfrm>
+          <a:off x="0" y="0"/>
+          <a:ext cx="0" cy="0"/>
+          <a:chOff x="0" y="0"/>
+          <a:chExt cx="0" cy="0"/>
+        </a:xfrm>
+      </p:grpSpPr>
+      <p:pic>
+        <p:nvPicPr>
+          <p:cNvPr id="5" name="Picture 4">
+            <a:extLst>
+              <a:ext uri="{FF2B5EF4-FFF2-40B4-BE49-F238E27FC236}">
+                <a16:creationId xmlns:a16="http://schemas.microsoft.com/office/drawing/2014/main" id="{802CC107-9FFD-BBFB-A181-68528F936C36}"/>
+              </a:ext>
+            </a:extLst>
+          </p:cNvPr>
+          <p:cNvPicPr>
+            <a:picLocks noChangeAspect="1"/>
+          </p:cNvPicPr>
+          <p:nvPr/>
+        </p:nvPicPr>
+        <p:blipFill>
+          <a:blip r:embed="rId3">
+            <a:extLst>
+              <a:ext uri="{28A0092B-C50C-407E-A947-70E740481C1C}">
+                <a14:useLocalDpi xmlns:a14="http://schemas.microsoft.com/office/drawing/2010/main" val="0"/>
+              </a:ext>
+            </a:extLst>
+          </a:blip>
+          <a:stretch>
+            <a:fillRect/>
+          </a:stretch>
+        </p:blipFill>
+        <p:spPr>
+          <a:xfrm>
+            <a:off x="995280" y="265758"/>
+            <a:ext cx="7959957" cy="6592242"/>
+          </a:xfrm>
+          <a:prstGeom prst="rect">
+            <a:avLst/>
+          </a:prstGeom>
+        </p:spPr>
+      </p:pic>
+      <p:sp>
+        <p:nvSpPr>
+          <p:cNvPr id="2" name="Title 3">
+            <a:extLst>
+              <a:ext uri="{FF2B5EF4-FFF2-40B4-BE49-F238E27FC236}">
+                <a16:creationId xmlns:a16="http://schemas.microsoft.com/office/drawing/2014/main" id="{69000D8A-D2B6-F5E9-D10B-BB92EFCCB37D}"/>
+              </a:ext>
+            </a:extLst>
+          </p:cNvPr>
+          <p:cNvSpPr txBox="1">
+            <a:spLocks/>
+          </p:cNvSpPr>
+          <p:nvPr/>
+        </p:nvSpPr>
+        <p:spPr>
+          <a:xfrm>
+            <a:off x="4631918" y="170671"/>
+            <a:ext cx="7359704" cy="629121"/>
+          </a:xfrm>
+          <a:prstGeom prst="rect">
+            <a:avLst/>
+          </a:prstGeom>
+        </p:spPr>
+        <p:txBody>
+          <a:bodyPr/>
+          <a:lstStyle>
+            <a:lvl1pPr algn="l" defTabSz="914400" rtl="0" eaLnBrk="1" latinLnBrk="0" hangingPunct="1">
+              <a:lnSpc>
+                <a:spcPct val="90000"/>
+              </a:lnSpc>
+              <a:spcBef>
+                <a:spcPct val="0"/>
+              </a:spcBef>
+              <a:buNone/>
+              <a:defRPr sz="4400" kern="1200">
+                <a:solidFill>
+                  <a:schemeClr val="tx1"/>
+                </a:solidFill>
+                <a:latin typeface="+mj-lt"/>
+                <a:ea typeface="+mj-ea"/>
+                <a:cs typeface="+mj-cs"/>
+              </a:defRPr>
+            </a:lvl1pPr>
+          </a:lstStyle>
+          <a:p>
+            <a:r>
+              <a:rPr lang="en-US" dirty="0"/>
+              <a:t>Prev minus WT elegans and P</a:t>
+            </a:r>
+          </a:p>
+        </p:txBody>
+      </p:sp>
+    </p:spTree>
+    <p:extLst>
+      <p:ext uri="{BB962C8B-B14F-4D97-AF65-F5344CB8AC3E}">
+        <p14:creationId xmlns:p14="http://schemas.microsoft.com/office/powerpoint/2010/main" val="4208517190"/>
+      </p:ext>
+    </p:extLst>
+  </p:cSld>
+  <p:clrMapOvr>
+    <a:masterClrMapping/>
+  </p:clrMapOvr>
+</p:sld>
+</file>
+
+<file path=ppt/slides/slide5.xml><?xml version="1.0" encoding="utf-8"?>
+<p:sld xmlns:a="http://schemas.openxmlformats.org/drawingml/2006/main" xmlns:r="http://schemas.openxmlformats.org/officeDocument/2006/relationships" xmlns:p="http://schemas.openxmlformats.org/presentationml/2006/main">
+  <p:cSld>
+    <p:spTree>
+      <p:nvGrpSpPr>
+        <p:cNvPr id="1" name=""/>
+        <p:cNvGrpSpPr/>
+        <p:nvPr/>
+      </p:nvGrpSpPr>
+      <p:grpSpPr>
+        <a:xfrm>
+          <a:off x="0" y="0"/>
+          <a:ext cx="0" cy="0"/>
+          <a:chOff x="0" y="0"/>
+          <a:chExt cx="0" cy="0"/>
+        </a:xfrm>
+      </p:grpSpPr>
+      <p:pic>
+        <p:nvPicPr>
+          <p:cNvPr id="3" name="Picture 2">
+            <a:extLst>
+              <a:ext uri="{FF2B5EF4-FFF2-40B4-BE49-F238E27FC236}">
+                <a16:creationId xmlns:a16="http://schemas.microsoft.com/office/drawing/2014/main" id="{9E1181FD-800A-91F5-EE1F-ECB408BCBE31}"/>
+              </a:ext>
+            </a:extLst>
+          </p:cNvPr>
+          <p:cNvPicPr>
+            <a:picLocks noChangeAspect="1"/>
+          </p:cNvPicPr>
+          <p:nvPr/>
+        </p:nvPicPr>
+        <p:blipFill>
+          <a:blip r:embed="rId2">
+            <a:extLst>
+              <a:ext uri="{28A0092B-C50C-407E-A947-70E740481C1C}">
+                <a14:useLocalDpi xmlns:a14="http://schemas.microsoft.com/office/drawing/2010/main" val="0"/>
+              </a:ext>
+            </a:extLst>
+          </a:blip>
+          <a:stretch>
+            <a:fillRect/>
+          </a:stretch>
+        </p:blipFill>
+        <p:spPr>
+          <a:xfrm>
+            <a:off x="1765573" y="360168"/>
+            <a:ext cx="8941938" cy="6136243"/>
+          </a:xfrm>
+          <a:prstGeom prst="rect">
+            <a:avLst/>
+          </a:prstGeom>
+        </p:spPr>
+      </p:pic>
+      <p:sp>
+        <p:nvSpPr>
+          <p:cNvPr id="4" name="Title 3">
+            <a:extLst>
+              <a:ext uri="{FF2B5EF4-FFF2-40B4-BE49-F238E27FC236}">
+                <a16:creationId xmlns:a16="http://schemas.microsoft.com/office/drawing/2014/main" id="{330EB7E6-904B-9CF3-4089-D74ED26A367C}"/>
+              </a:ext>
+            </a:extLst>
+          </p:cNvPr>
+          <p:cNvSpPr>
+            <a:spLocks noGrp="1"/>
+          </p:cNvSpPr>
+          <p:nvPr>
+            <p:ph type="title"/>
+          </p:nvPr>
+        </p:nvSpPr>
+        <p:spPr>
+          <a:xfrm>
+            <a:off x="191911" y="-158044"/>
+            <a:ext cx="10515600" cy="1325563"/>
+          </a:xfrm>
+        </p:spPr>
+        <p:txBody>
+          <a:bodyPr/>
+          <a:lstStyle/>
+          <a:p>
+            <a:r>
+              <a:rPr lang="en-US" dirty="0"/>
+              <a:t>All WT</a:t>
+            </a:r>
+          </a:p>
+        </p:txBody>
+      </p:sp>
+    </p:spTree>
+    <p:extLst>
+      <p:ext uri="{BB962C8B-B14F-4D97-AF65-F5344CB8AC3E}">
+        <p14:creationId xmlns:p14="http://schemas.microsoft.com/office/powerpoint/2010/main" val="2012754573"/>
+      </p:ext>
+    </p:extLst>
+  </p:cSld>
+  <p:clrMapOvr>
+    <a:masterClrMapping/>
+  </p:clrMapOvr>
+</p:sld>
+</file>
+
+<file path=ppt/slides/slide6.xml><?xml version="1.0" encoding="utf-8"?>
+<p:sld xmlns:a="http://schemas.openxmlformats.org/drawingml/2006/main" xmlns:r="http://schemas.openxmlformats.org/officeDocument/2006/relationships" xmlns:p="http://schemas.openxmlformats.org/presentationml/2006/main">
+  <p:cSld>
+    <p:spTree>
+      <p:nvGrpSpPr>
+        <p:cNvPr id="1" name=""/>
+        <p:cNvGrpSpPr/>
+        <p:nvPr/>
+      </p:nvGrpSpPr>
+      <p:grpSpPr>
+        <a:xfrm>
+          <a:off x="0" y="0"/>
+          <a:ext cx="0" cy="0"/>
+          <a:chOff x="0" y="0"/>
+          <a:chExt cx="0" cy="0"/>
+        </a:xfrm>
+      </p:grpSpPr>
+      <p:pic>
+        <p:nvPicPr>
+          <p:cNvPr id="31" name="Picture 30">
+            <a:extLst>
+              <a:ext uri="{FF2B5EF4-FFF2-40B4-BE49-F238E27FC236}">
+                <a16:creationId xmlns:a16="http://schemas.microsoft.com/office/drawing/2014/main" id="{4F500660-B97C-7AFD-62DA-A418B27FFFE5}"/>
+              </a:ext>
+            </a:extLst>
+          </p:cNvPr>
+          <p:cNvPicPr>
+            <a:picLocks noChangeAspect="1"/>
+          </p:cNvPicPr>
+          <p:nvPr/>
+        </p:nvPicPr>
+        <p:blipFill>
+          <a:blip r:embed="rId3">
+            <a:extLst>
+              <a:ext uri="{28A0092B-C50C-407E-A947-70E740481C1C}">
+                <a14:useLocalDpi xmlns:a14="http://schemas.microsoft.com/office/drawing/2010/main" val="0"/>
+              </a:ext>
+            </a:extLst>
+          </a:blip>
+          <a:stretch>
+            <a:fillRect/>
+          </a:stretch>
+        </p:blipFill>
+        <p:spPr>
+          <a:xfrm>
+            <a:off x="2483125" y="580104"/>
+            <a:ext cx="7658370" cy="6342475"/>
+          </a:xfrm>
+          <a:prstGeom prst="rect">
+            <a:avLst/>
+          </a:prstGeom>
+        </p:spPr>
+      </p:pic>
+      <p:sp>
+        <p:nvSpPr>
+          <p:cNvPr id="2" name="Title 1">
+            <a:extLst>
+              <a:ext uri="{FF2B5EF4-FFF2-40B4-BE49-F238E27FC236}">
+                <a16:creationId xmlns:a16="http://schemas.microsoft.com/office/drawing/2014/main" id="{8CFE8FC2-74F4-9BB5-D225-735858BA7BC7}"/>
+              </a:ext>
+            </a:extLst>
+          </p:cNvPr>
+          <p:cNvSpPr>
+            <a:spLocks noGrp="1"/>
+          </p:cNvSpPr>
+          <p:nvPr>
+            <p:ph type="title"/>
+          </p:nvPr>
+        </p:nvSpPr>
+        <p:spPr>
+          <a:xfrm>
+            <a:off x="149942" y="156572"/>
+            <a:ext cx="6162368" cy="423532"/>
+          </a:xfrm>
+        </p:spPr>
+        <p:txBody>
+          <a:bodyPr>
+            <a:normAutofit fontScale="90000"/>
+          </a:bodyPr>
+          <a:lstStyle/>
+          <a:p>
+            <a:r>
+              <a:rPr lang="en-US" dirty="0"/>
+              <a:t>LVNV, T, WT sirtalis</a:t>
+            </a:r>
+          </a:p>
+        </p:txBody>
+      </p:sp>
+    </p:spTree>
+    <p:extLst>
+      <p:ext uri="{BB962C8B-B14F-4D97-AF65-F5344CB8AC3E}">
+        <p14:creationId xmlns:p14="http://schemas.microsoft.com/office/powerpoint/2010/main" val="3596044053"/>
+      </p:ext>
+    </p:extLst>
+  </p:cSld>
+  <p:clrMapOvr>
+    <a:masterClrMapping/>
+  </p:clrMapOvr>
+</p:sld>
+</file>
+
+<file path=ppt/slides/slide7.xml><?xml version="1.0" encoding="utf-8"?>
+<p:sld xmlns:a="http://schemas.openxmlformats.org/drawingml/2006/main" xmlns:r="http://schemas.openxmlformats.org/officeDocument/2006/relationships" xmlns:p="http://schemas.openxmlformats.org/presentationml/2006/main">
+  <p:cSld>
+    <p:spTree>
+      <p:nvGrpSpPr>
+        <p:cNvPr id="1" name=""/>
+        <p:cNvGrpSpPr/>
+        <p:nvPr/>
+      </p:nvGrpSpPr>
+      <p:grpSpPr>
+        <a:xfrm>
+          <a:off x="0" y="0"/>
+          <a:ext cx="0" cy="0"/>
+          <a:chOff x="0" y="0"/>
+          <a:chExt cx="0" cy="0"/>
+        </a:xfrm>
+      </p:grpSpPr>
+      <p:pic>
+        <p:nvPicPr>
+          <p:cNvPr id="29" name="Picture 28">
+            <a:extLst>
+              <a:ext uri="{FF2B5EF4-FFF2-40B4-BE49-F238E27FC236}">
+                <a16:creationId xmlns:a16="http://schemas.microsoft.com/office/drawing/2014/main" id="{2DBBFDC0-9179-B2DE-3509-8AABFAFBB859}"/>
+              </a:ext>
+            </a:extLst>
+          </p:cNvPr>
+          <p:cNvPicPr>
+            <a:picLocks noChangeAspect="1"/>
+          </p:cNvPicPr>
+          <p:nvPr/>
+        </p:nvPicPr>
+        <p:blipFill>
+          <a:blip r:embed="rId3">
+            <a:extLst>
+              <a:ext uri="{28A0092B-C50C-407E-A947-70E740481C1C}">
+                <a14:useLocalDpi xmlns:a14="http://schemas.microsoft.com/office/drawing/2010/main" val="0"/>
+              </a:ext>
+            </a:extLst>
+          </a:blip>
+          <a:stretch>
+            <a:fillRect/>
+          </a:stretch>
+        </p:blipFill>
+        <p:spPr>
+          <a:xfrm>
+            <a:off x="2470331" y="743132"/>
+            <a:ext cx="7251338" cy="6005381"/>
+          </a:xfrm>
+          <a:prstGeom prst="rect">
+            <a:avLst/>
+          </a:prstGeom>
+        </p:spPr>
+      </p:pic>
+      <p:sp>
+        <p:nvSpPr>
+          <p:cNvPr id="3" name="Title 2">
+            <a:extLst>
+              <a:ext uri="{FF2B5EF4-FFF2-40B4-BE49-F238E27FC236}">
+                <a16:creationId xmlns:a16="http://schemas.microsoft.com/office/drawing/2014/main" id="{1B066AFE-3330-875C-2992-77ECA537184C}"/>
+              </a:ext>
+            </a:extLst>
+          </p:cNvPr>
+          <p:cNvSpPr>
+            <a:spLocks noGrp="1"/>
+          </p:cNvSpPr>
+          <p:nvPr>
+            <p:ph type="title"/>
+          </p:nvPr>
+        </p:nvSpPr>
+        <p:spPr>
+          <a:xfrm>
+            <a:off x="130277" y="109487"/>
+            <a:ext cx="9869129" cy="667262"/>
+          </a:xfrm>
+        </p:spPr>
+        <p:txBody>
+          <a:bodyPr>
+            <a:normAutofit fontScale="90000"/>
+          </a:bodyPr>
+          <a:lstStyle/>
+          <a:p>
+            <a:r>
+              <a:rPr lang="en-US" dirty="0"/>
+              <a:t>EPN, LVNV, T, WT sirtalis</a:t>
+            </a:r>
+          </a:p>
+        </p:txBody>
+      </p:sp>
+    </p:spTree>
+    <p:extLst>
+      <p:ext uri="{BB962C8B-B14F-4D97-AF65-F5344CB8AC3E}">
+        <p14:creationId xmlns:p14="http://schemas.microsoft.com/office/powerpoint/2010/main" val="959217749"/>
+      </p:ext>
+    </p:extLst>
+  </p:cSld>
+  <p:clrMapOvr>
+    <a:masterClrMapping/>
+  </p:clrMapOvr>
+</p:sld>
+</file>
+
+<file path=ppt/slides/slide8.xml><?xml version="1.0" encoding="utf-8"?>
+<p:sld xmlns:a="http://schemas.openxmlformats.org/drawingml/2006/main" xmlns:r="http://schemas.openxmlformats.org/officeDocument/2006/relationships" xmlns:p="http://schemas.openxmlformats.org/presentationml/2006/main">
+  <p:cSld>
+    <p:spTree>
+      <p:nvGrpSpPr>
+        <p:cNvPr id="1" name=""/>
+        <p:cNvGrpSpPr/>
+        <p:nvPr/>
+      </p:nvGrpSpPr>
+      <p:grpSpPr>
+        <a:xfrm>
+          <a:off x="0" y="0"/>
+          <a:ext cx="0" cy="0"/>
+          <a:chOff x="0" y="0"/>
+          <a:chExt cx="0" cy="0"/>
+        </a:xfrm>
+      </p:grpSpPr>
+      <p:pic>
+        <p:nvPicPr>
+          <p:cNvPr id="21" name="Picture 20">
+            <a:extLst>
+              <a:ext uri="{FF2B5EF4-FFF2-40B4-BE49-F238E27FC236}">
+                <a16:creationId xmlns:a16="http://schemas.microsoft.com/office/drawing/2014/main" id="{ABBD96AC-A510-4B21-1CAD-CD4AA3181743}"/>
+              </a:ext>
+            </a:extLst>
+          </p:cNvPr>
+          <p:cNvPicPr>
+            <a:picLocks noChangeAspect="1"/>
+          </p:cNvPicPr>
+          <p:nvPr/>
+        </p:nvPicPr>
+        <p:blipFill>
+          <a:blip r:embed="rId3">
+            <a:extLst>
+              <a:ext uri="{28A0092B-C50C-407E-A947-70E740481C1C}">
+                <a14:useLocalDpi xmlns:a14="http://schemas.microsoft.com/office/drawing/2010/main" val="0"/>
+              </a:ext>
+            </a:extLst>
+          </a:blip>
+          <a:stretch>
+            <a:fillRect/>
+          </a:stretch>
+        </p:blipFill>
+        <p:spPr>
+          <a:xfrm>
+            <a:off x="2273570" y="597654"/>
+            <a:ext cx="7644860" cy="6331286"/>
+          </a:xfrm>
+          <a:prstGeom prst="rect">
+            <a:avLst/>
+          </a:prstGeom>
+        </p:spPr>
+      </p:pic>
+      <p:sp>
+        <p:nvSpPr>
+          <p:cNvPr id="2" name="Title 1">
+            <a:extLst>
+              <a:ext uri="{FF2B5EF4-FFF2-40B4-BE49-F238E27FC236}">
+                <a16:creationId xmlns:a16="http://schemas.microsoft.com/office/drawing/2014/main" id="{9E1B3FD0-DCB1-7C76-EB70-5B896BA4D7A4}"/>
+              </a:ext>
+            </a:extLst>
+          </p:cNvPr>
+          <p:cNvSpPr>
+            <a:spLocks noGrp="1"/>
+          </p:cNvSpPr>
+          <p:nvPr>
+            <p:ph type="title"/>
+          </p:nvPr>
+        </p:nvSpPr>
+        <p:spPr>
+          <a:xfrm>
+            <a:off x="159774" y="263357"/>
+            <a:ext cx="9080230" cy="175649"/>
+          </a:xfrm>
+        </p:spPr>
+        <p:txBody>
+          <a:bodyPr>
+            <a:normAutofit fontScale="90000"/>
+          </a:bodyPr>
+          <a:lstStyle/>
+          <a:p>
+            <a:r>
+              <a:rPr lang="en-US" dirty="0"/>
+              <a:t>T, LVNV, WT sirtalis, </a:t>
+            </a:r>
+            <a:r>
+              <a:rPr lang="en-US" dirty="0" err="1"/>
+              <a:t>hammondii</a:t>
+            </a:r>
+            <a:endParaRPr lang="en-US" dirty="0"/>
+          </a:p>
+        </p:txBody>
+      </p:sp>
+    </p:spTree>
+    <p:extLst>
+      <p:ext uri="{BB962C8B-B14F-4D97-AF65-F5344CB8AC3E}">
+        <p14:creationId xmlns:p14="http://schemas.microsoft.com/office/powerpoint/2010/main" val="3843965665"/>
+      </p:ext>
+    </p:extLst>
+  </p:cSld>
+  <p:clrMapOvr>
+    <a:masterClrMapping/>
+  </p:clrMapOvr>
+</p:sld>
+</file>
+
+<file path=ppt/slides/slide9.xml><?xml version="1.0" encoding="utf-8"?>
+<p:sld xmlns:a="http://schemas.openxmlformats.org/drawingml/2006/main" xmlns:r="http://schemas.openxmlformats.org/officeDocument/2006/relationships" xmlns:p="http://schemas.openxmlformats.org/presentationml/2006/main">
+  <p:cSld>
+    <p:spTree>
+      <p:nvGrpSpPr>
+        <p:cNvPr id="1" name=""/>
+        <p:cNvGrpSpPr/>
+        <p:nvPr/>
+      </p:nvGrpSpPr>
+      <p:grpSpPr>
+        <a:xfrm>
+          <a:off x="0" y="0"/>
+          <a:ext cx="0" cy="0"/>
+          <a:chOff x="0" y="0"/>
+          <a:chExt cx="0" cy="0"/>
+        </a:xfrm>
+      </p:grpSpPr>
+      <p:pic>
+        <p:nvPicPr>
+          <p:cNvPr id="23" name="Picture 22">
+            <a:extLst>
+              <a:ext uri="{FF2B5EF4-FFF2-40B4-BE49-F238E27FC236}">
+                <a16:creationId xmlns:a16="http://schemas.microsoft.com/office/drawing/2014/main" id="{20FF2F85-7B1C-51EB-2A21-E2C82DD1DB61}"/>
+              </a:ext>
+            </a:extLst>
+          </p:cNvPr>
+          <p:cNvPicPr>
+            <a:picLocks noChangeAspect="1"/>
+          </p:cNvPicPr>
+          <p:nvPr/>
+        </p:nvPicPr>
+        <p:blipFill>
+          <a:blip r:embed="rId3">
+            <a:extLst>
+              <a:ext uri="{28A0092B-C50C-407E-A947-70E740481C1C}">
+                <a14:useLocalDpi xmlns:a14="http://schemas.microsoft.com/office/drawing/2010/main" val="0"/>
+              </a:ext>
+            </a:extLst>
+          </a:blip>
+          <a:stretch>
+            <a:fillRect/>
+          </a:stretch>
+        </p:blipFill>
+        <p:spPr>
+          <a:xfrm>
+            <a:off x="2191850" y="529312"/>
+            <a:ext cx="7808299" cy="6466642"/>
+          </a:xfrm>
+          <a:prstGeom prst="rect">
+            <a:avLst/>
+          </a:prstGeom>
+        </p:spPr>
+      </p:pic>
+      <p:pic>
+        <p:nvPicPr>
+          <p:cNvPr id="4" name="Picture 3">
+            <a:extLst>
+              <a:ext uri="{FF2B5EF4-FFF2-40B4-BE49-F238E27FC236}">
+                <a16:creationId xmlns:a16="http://schemas.microsoft.com/office/drawing/2014/main" id="{B11CAAF9-DF87-20B5-B87E-C1F8AE1B399C}"/>
+              </a:ext>
+            </a:extLst>
+          </p:cNvPr>
+          <p:cNvPicPr>
+            <a:picLocks noChangeAspect="1"/>
+          </p:cNvPicPr>
+          <p:nvPr/>
+        </p:nvPicPr>
+        <p:blipFill>
+          <a:blip r:embed="rId4"/>
+          <a:stretch>
+            <a:fillRect/>
+          </a:stretch>
+        </p:blipFill>
+        <p:spPr>
+          <a:xfrm>
+            <a:off x="-165093" y="-86075"/>
+            <a:ext cx="9297206" cy="1072989"/>
+          </a:xfrm>
+          <a:prstGeom prst="rect">
+            <a:avLst/>
+          </a:prstGeom>
+        </p:spPr>
+      </p:pic>
+    </p:spTree>
+    <p:extLst>
+      <p:ext uri="{BB962C8B-B14F-4D97-AF65-F5344CB8AC3E}">
+        <p14:creationId xmlns:p14="http://schemas.microsoft.com/office/powerpoint/2010/main" val="692453888"/>
       </p:ext>
     </p:extLst>
   </p:cSld>

</xml_diff>